<commit_message>
vault backup: 2026-06-02 15:04:30
</commit_message>
<xml_diff>
--- a/Coaching/Business Advisory Services/A001/A001 — Presentation Deck 3.pptx
+++ b/Coaching/Business Advisory Services/A001/A001 — Presentation Deck 3.pptx
@@ -6,13 +6,13 @@
   </p:sldMasterIdLst>
   <p:sldIdLst>
     <p:sldId id="256" r:id="rId7"/>
-    <p:sldId id="257" r:id="rId8"/>
-    <p:sldId id="258" r:id="rId9"/>
-    <p:sldId id="259" r:id="rId10"/>
-    <p:sldId id="260" r:id="rId11"/>
-    <p:sldId id="261" r:id="rId12"/>
+    <p:sldId id="257" r:id="rId9"/>
+    <p:sldId id="258" r:id="rId10"/>
+    <p:sldId id="259" r:id="rId11"/>
+    <p:sldId id="260" r:id="rId12"/>
+    <p:sldId id="261" r:id="rId13"/>
   </p:sldIdLst>
-  <p:sldSz cx="12191695" cy="6858000" type="screen4x3"/>
+  <p:sldSz cx="12188952" cy="6858000" type="screen4x3"/>
   <p:notesSz cx="6858000" cy="9144000"/>
   <p:defaultTextStyle>
     <a:defPPr>
@@ -110,6 +110,872 @@
     </a:lvl9pPr>
   </p:defaultTextStyle>
 </p:presentation>
+</file>
+
+<file path=ppt/notesMasters/notesMaster1.xml><?xml version="1.0" encoding="utf-8"?>
+<p:notesMaster xmlns:a="http://schemas.openxmlformats.org/drawingml/2006/main" xmlns:p="http://schemas.openxmlformats.org/presentationml/2006/main" xmlns:r="http://schemas.openxmlformats.org/officeDocument/2006/relationships">
+  <p:cSld>
+    <p:bg>
+      <p:bgRef idx="1001">
+        <a:schemeClr val="bg1"/>
+      </p:bgRef>
+    </p:bg>
+    <p:spTree>
+      <p:nvGrpSpPr>
+        <p:cNvPr id="1" name=""/>
+        <p:cNvGrpSpPr/>
+        <p:nvPr/>
+      </p:nvGrpSpPr>
+      <p:grpSpPr>
+        <a:xfrm>
+          <a:off x="0" y="0"/>
+          <a:ext cx="0" cy="0"/>
+          <a:chOff x="0" y="0"/>
+          <a:chExt cx="0" cy="0"/>
+        </a:xfrm>
+      </p:grpSpPr>
+      <p:sp>
+        <p:nvSpPr>
+          <p:cNvPr id="2" name="Header Placeholder 1"/>
+          <p:cNvSpPr>
+            <a:spLocks noGrp="1"/>
+          </p:cNvSpPr>
+          <p:nvPr>
+            <p:ph type="hdr" sz="quarter"/>
+          </p:nvPr>
+        </p:nvSpPr>
+        <p:spPr>
+          <a:xfrm>
+            <a:off x="0" y="0"/>
+            <a:ext cx="2971800" cy="457200"/>
+          </a:xfrm>
+          <a:prstGeom prst="rect">
+            <a:avLst/>
+          </a:prstGeom>
+        </p:spPr>
+        <p:txBody>
+          <a:bodyPr vert="horz" lIns="91440" tIns="45720" rIns="91440" bIns="45720" rtlCol="0"/>
+          <a:lstStyle>
+            <a:lvl1pPr algn="l">
+              <a:defRPr sz="1200"/>
+            </a:lvl1pPr>
+          </a:lstStyle>
+          <a:p>
+            <a:endParaRPr lang="en-US"/>
+          </a:p>
+        </p:txBody>
+      </p:sp>
+      <p:sp>
+        <p:nvSpPr>
+          <p:cNvPr id="3" name="Date Placeholder 2"/>
+          <p:cNvSpPr>
+            <a:spLocks noGrp="1"/>
+          </p:cNvSpPr>
+          <p:nvPr>
+            <p:ph type="dt" idx="1"/>
+          </p:nvPr>
+        </p:nvSpPr>
+        <p:spPr>
+          <a:xfrm>
+            <a:off x="3884613" y="0"/>
+            <a:ext cx="2971800" cy="457200"/>
+          </a:xfrm>
+          <a:prstGeom prst="rect">
+            <a:avLst/>
+          </a:prstGeom>
+        </p:spPr>
+        <p:txBody>
+          <a:bodyPr vert="horz" lIns="91440" tIns="45720" rIns="91440" bIns="45720" rtlCol="0"/>
+          <a:lstStyle>
+            <a:lvl1pPr algn="r">
+              <a:defRPr sz="1200"/>
+            </a:lvl1pPr>
+          </a:lstStyle>
+          <a:p>
+            <a:fld id="{0F89C1C7-3DCD-1040-A9CF-14679D8B5DDD}" type="datetimeFigureOut">
+              <a:rPr lang="en-US" smtClean="0"/>
+              <a:t>10/17/16</a:t>
+            </a:fld>
+            <a:endParaRPr lang="en-US"/>
+          </a:p>
+        </p:txBody>
+      </p:sp>
+      <p:sp>
+        <p:nvSpPr>
+          <p:cNvPr id="4" name="Slide Image Placeholder 3"/>
+          <p:cNvSpPr>
+            <a:spLocks noGrp="1" noRot="1" noChangeAspect="1"/>
+          </p:cNvSpPr>
+          <p:nvPr>
+            <p:ph type="sldImg" idx="2"/>
+          </p:nvPr>
+        </p:nvSpPr>
+        <p:spPr>
+          <a:xfrm>
+            <a:off x="1143000" y="685800"/>
+            <a:ext cx="4572000" cy="3429000"/>
+          </a:xfrm>
+          <a:prstGeom prst="rect">
+            <a:avLst/>
+          </a:prstGeom>
+          <a:noFill/>
+          <a:ln w="12700">
+            <a:solidFill>
+              <a:prstClr val="black"/>
+            </a:solidFill>
+          </a:ln>
+        </p:spPr>
+        <p:txBody>
+          <a:bodyPr vert="horz" lIns="91440" tIns="45720" rIns="91440" bIns="45720" rtlCol="0" anchor="ctr"/>
+          <a:lstStyle/>
+          <a:p>
+            <a:endParaRPr lang="en-US"/>
+          </a:p>
+        </p:txBody>
+      </p:sp>
+      <p:sp>
+        <p:nvSpPr>
+          <p:cNvPr id="5" name="Notes Placeholder 4"/>
+          <p:cNvSpPr>
+            <a:spLocks noGrp="1"/>
+          </p:cNvSpPr>
+          <p:nvPr>
+            <p:ph type="body" sz="quarter" idx="3"/>
+          </p:nvPr>
+        </p:nvSpPr>
+        <p:spPr>
+          <a:xfrm>
+            <a:off x="685800" y="4343400"/>
+            <a:ext cx="5486400" cy="4114800"/>
+          </a:xfrm>
+          <a:prstGeom prst="rect">
+            <a:avLst/>
+          </a:prstGeom>
+        </p:spPr>
+        <p:txBody>
+          <a:bodyPr vert="horz" lIns="91440" tIns="45720" rIns="91440" bIns="45720" rtlCol="0"/>
+          <a:lstStyle/>
+          <a:p>
+            <a:pPr lvl="0"/>
+            <a:r>
+              <a:rPr lang="en-US" smtClean="0"/>
+              <a:t>Click to edit Master text styles</a:t>
+            </a:r>
+          </a:p>
+          <a:p>
+            <a:pPr lvl="1"/>
+            <a:r>
+              <a:rPr lang="en-US" smtClean="0"/>
+              <a:t>Second level</a:t>
+            </a:r>
+          </a:p>
+          <a:p>
+            <a:pPr lvl="2"/>
+            <a:r>
+              <a:rPr lang="en-US" smtClean="0"/>
+              <a:t>Third level</a:t>
+            </a:r>
+          </a:p>
+          <a:p>
+            <a:pPr lvl="3"/>
+            <a:r>
+              <a:rPr lang="en-US" smtClean="0"/>
+              <a:t>Fourth level</a:t>
+            </a:r>
+          </a:p>
+          <a:p>
+            <a:pPr lvl="4"/>
+            <a:r>
+              <a:rPr lang="en-US" smtClean="0"/>
+              <a:t>Fifth level</a:t>
+            </a:r>
+            <a:endParaRPr lang="en-US"/>
+          </a:p>
+        </p:txBody>
+      </p:sp>
+      <p:sp>
+        <p:nvSpPr>
+          <p:cNvPr id="6" name="Footer Placeholder 5"/>
+          <p:cNvSpPr>
+            <a:spLocks noGrp="1"/>
+          </p:cNvSpPr>
+          <p:nvPr>
+            <p:ph type="ftr" sz="quarter" idx="4"/>
+          </p:nvPr>
+        </p:nvSpPr>
+        <p:spPr>
+          <a:xfrm>
+            <a:off x="0" y="8685213"/>
+            <a:ext cx="2971800" cy="457200"/>
+          </a:xfrm>
+          <a:prstGeom prst="rect">
+            <a:avLst/>
+          </a:prstGeom>
+        </p:spPr>
+        <p:txBody>
+          <a:bodyPr vert="horz" lIns="91440" tIns="45720" rIns="91440" bIns="45720" rtlCol="0" anchor="b"/>
+          <a:lstStyle>
+            <a:lvl1pPr algn="l">
+              <a:defRPr sz="1200"/>
+            </a:lvl1pPr>
+          </a:lstStyle>
+          <a:p>
+            <a:endParaRPr lang="en-US"/>
+          </a:p>
+        </p:txBody>
+      </p:sp>
+      <p:sp>
+        <p:nvSpPr>
+          <p:cNvPr id="7" name="Slide Number Placeholder 6"/>
+          <p:cNvSpPr>
+            <a:spLocks noGrp="1"/>
+          </p:cNvSpPr>
+          <p:nvPr>
+            <p:ph type="sldNum" sz="quarter" idx="5"/>
+          </p:nvPr>
+        </p:nvSpPr>
+        <p:spPr>
+          <a:xfrm>
+            <a:off x="3884613" y="8685213"/>
+            <a:ext cx="2971800" cy="457200"/>
+          </a:xfrm>
+          <a:prstGeom prst="rect">
+            <a:avLst/>
+          </a:prstGeom>
+        </p:spPr>
+        <p:txBody>
+          <a:bodyPr vert="horz" lIns="91440" tIns="45720" rIns="91440" bIns="45720" rtlCol="0" anchor="b"/>
+          <a:lstStyle>
+            <a:lvl1pPr algn="r">
+              <a:defRPr sz="1200"/>
+            </a:lvl1pPr>
+          </a:lstStyle>
+          <a:p>
+            <a:fld id="{BB5E49A5-4136-284D-997B-48E1D791AD67}" type="slidenum">
+              <a:rPr lang="en-US" smtClean="0"/>
+              <a:t>‹#›</a:t>
+            </a:fld>
+            <a:endParaRPr lang="en-US"/>
+          </a:p>
+        </p:txBody>
+      </p:sp>
+    </p:spTree>
+    <p:extLst>
+      <p:ext uri="{BB962C8B-B14F-4D97-AF65-F5344CB8AC3E}">
+        <p14:creationId xmlns:p14="http://schemas.microsoft.com/office/powerpoint/2010/main" val="2623252185"/>
+      </p:ext>
+    </p:extLst>
+  </p:cSld>
+  <p:clrMap bg1="lt1" tx1="dk1" bg2="lt2" tx2="dk2" accent1="accent1" accent2="accent2" accent3="accent3" accent4="accent4" accent5="accent5" accent6="accent6" hlink="hlink" folHlink="folHlink"/>
+  <p:notesStyle>
+    <a:lvl1pPr marL="0" algn="l" defTabSz="457200" rtl="0" eaLnBrk="1" latinLnBrk="0" hangingPunct="1">
+      <a:defRPr sz="1200" kern="1200">
+        <a:solidFill>
+          <a:schemeClr val="tx1"/>
+        </a:solidFill>
+        <a:latin typeface="+mn-lt"/>
+        <a:ea typeface="+mn-ea"/>
+        <a:cs typeface="+mn-cs"/>
+      </a:defRPr>
+    </a:lvl1pPr>
+    <a:lvl2pPr marL="457200" algn="l" defTabSz="457200" rtl="0" eaLnBrk="1" latinLnBrk="0" hangingPunct="1">
+      <a:defRPr sz="1200" kern="1200">
+        <a:solidFill>
+          <a:schemeClr val="tx1"/>
+        </a:solidFill>
+        <a:latin typeface="+mn-lt"/>
+        <a:ea typeface="+mn-ea"/>
+        <a:cs typeface="+mn-cs"/>
+      </a:defRPr>
+    </a:lvl2pPr>
+    <a:lvl3pPr marL="914400" algn="l" defTabSz="457200" rtl="0" eaLnBrk="1" latinLnBrk="0" hangingPunct="1">
+      <a:defRPr sz="1200" kern="1200">
+        <a:solidFill>
+          <a:schemeClr val="tx1"/>
+        </a:solidFill>
+        <a:latin typeface="+mn-lt"/>
+        <a:ea typeface="+mn-ea"/>
+        <a:cs typeface="+mn-cs"/>
+      </a:defRPr>
+    </a:lvl3pPr>
+    <a:lvl4pPr marL="1371600" algn="l" defTabSz="457200" rtl="0" eaLnBrk="1" latinLnBrk="0" hangingPunct="1">
+      <a:defRPr sz="1200" kern="1200">
+        <a:solidFill>
+          <a:schemeClr val="tx1"/>
+        </a:solidFill>
+        <a:latin typeface="+mn-lt"/>
+        <a:ea typeface="+mn-ea"/>
+        <a:cs typeface="+mn-cs"/>
+      </a:defRPr>
+    </a:lvl4pPr>
+    <a:lvl5pPr marL="1828800" algn="l" defTabSz="457200" rtl="0" eaLnBrk="1" latinLnBrk="0" hangingPunct="1">
+      <a:defRPr sz="1200" kern="1200">
+        <a:solidFill>
+          <a:schemeClr val="tx1"/>
+        </a:solidFill>
+        <a:latin typeface="+mn-lt"/>
+        <a:ea typeface="+mn-ea"/>
+        <a:cs typeface="+mn-cs"/>
+      </a:defRPr>
+    </a:lvl5pPr>
+    <a:lvl6pPr marL="2286000" algn="l" defTabSz="457200" rtl="0" eaLnBrk="1" latinLnBrk="0" hangingPunct="1">
+      <a:defRPr sz="1200" kern="1200">
+        <a:solidFill>
+          <a:schemeClr val="tx1"/>
+        </a:solidFill>
+        <a:latin typeface="+mn-lt"/>
+        <a:ea typeface="+mn-ea"/>
+        <a:cs typeface="+mn-cs"/>
+      </a:defRPr>
+    </a:lvl6pPr>
+    <a:lvl7pPr marL="2743200" algn="l" defTabSz="457200" rtl="0" eaLnBrk="1" latinLnBrk="0" hangingPunct="1">
+      <a:defRPr sz="1200" kern="1200">
+        <a:solidFill>
+          <a:schemeClr val="tx1"/>
+        </a:solidFill>
+        <a:latin typeface="+mn-lt"/>
+        <a:ea typeface="+mn-ea"/>
+        <a:cs typeface="+mn-cs"/>
+      </a:defRPr>
+    </a:lvl7pPr>
+    <a:lvl8pPr marL="3200400" algn="l" defTabSz="457200" rtl="0" eaLnBrk="1" latinLnBrk="0" hangingPunct="1">
+      <a:defRPr sz="1200" kern="1200">
+        <a:solidFill>
+          <a:schemeClr val="tx1"/>
+        </a:solidFill>
+        <a:latin typeface="+mn-lt"/>
+        <a:ea typeface="+mn-ea"/>
+        <a:cs typeface="+mn-cs"/>
+      </a:defRPr>
+    </a:lvl8pPr>
+    <a:lvl9pPr marL="3657600" algn="l" defTabSz="457200" rtl="0" eaLnBrk="1" latinLnBrk="0" hangingPunct="1">
+      <a:defRPr sz="1200" kern="1200">
+        <a:solidFill>
+          <a:schemeClr val="tx1"/>
+        </a:solidFill>
+        <a:latin typeface="+mn-lt"/>
+        <a:ea typeface="+mn-ea"/>
+        <a:cs typeface="+mn-cs"/>
+      </a:defRPr>
+    </a:lvl9pPr>
+  </p:notesStyle>
+</p:notesMaster>
+</file>
+
+<file path=ppt/notesSlides/notesSlide1.xml><?xml version="1.0" encoding="utf-8"?>
+<p:notes xmlns:a="http://schemas.openxmlformats.org/drawingml/2006/main" xmlns:p="http://schemas.openxmlformats.org/presentationml/2006/main" xmlns:r="http://schemas.openxmlformats.org/officeDocument/2006/relationships">
+  <p:cSld>
+    <p:spTree>
+      <p:nvGrpSpPr>
+        <p:cNvPr id="1" name=""/>
+        <p:cNvGrpSpPr/>
+        <p:nvPr/>
+      </p:nvGrpSpPr>
+      <p:grpSpPr>
+        <a:xfrm>
+          <a:off x="0" y="0"/>
+          <a:ext cx="0" cy="0"/>
+          <a:chOff x="0" y="0"/>
+          <a:chExt cx="0" cy="0"/>
+        </a:xfrm>
+      </p:grpSpPr>
+      <p:sp>
+        <p:nvSpPr>
+          <p:cNvPr id="2" name="Slide Image Placeholder 1"/>
+          <p:cNvSpPr>
+            <a:spLocks noGrp="1"/>
+          </p:cNvSpPr>
+          <p:nvPr>
+            <p:ph type="sldImg" idx="2"/>
+          </p:nvPr>
+        </p:nvSpPr>
+        <p:spPr/>
+      </p:sp>
+      <p:sp>
+        <p:nvSpPr>
+          <p:cNvPr id="3" name="Notes Placeholder 2"/>
+          <p:cNvSpPr>
+            <a:spLocks noGrp="1"/>
+          </p:cNvSpPr>
+          <p:nvPr>
+            <p:ph type="body" idx="3" sz="quarter"/>
+          </p:nvPr>
+        </p:nvSpPr>
+        <p:spPr/>
+        <p:txBody>
+          <a:bodyPr/>
+          <a:lstStyle/>
+          <a:p>
+            <a:r>
+              <a:t>"You've already named this — you identified at [coffee shop] that the behavior is coming from the environment, not the character of your people. This is why training doesn't stick. It changes what people know. It doesn't change the conditions that activated the pattern in the first place. When the manager walks back into the same environment, the same conditions produce the same behavior. What's different here is that we work at the level where the pattern is actually produced."</a:t>
+            </a:r>
+          </a:p>
+          <a:p/>
+          <a:p>
+            <a:r>
+              <a:t>Deploy when: Owner mentions prior training that failed, OR asks "why does this keep happening?"</a:t>
+            </a:r>
+          </a:p>
+          <a:p>
+            <a:r>
+              <a:t>Duration: 60–75 seconds</a:t>
+            </a:r>
+          </a:p>
+          <a:p>
+            <a:r>
+              <a:t>Put away when: Owner acknowledges the distinction — any verbal signal that it landed</a:t>
+            </a:r>
+          </a:p>
+        </p:txBody>
+      </p:sp>
+      <p:sp>
+        <p:nvSpPr>
+          <p:cNvPr id="4" name="Slide Number Placeholder 3"/>
+          <p:cNvSpPr>
+            <a:spLocks noGrp="1"/>
+          </p:cNvSpPr>
+          <p:nvPr>
+            <p:ph type="sldNum" idx="5" sz="quarter"/>
+          </p:nvPr>
+        </p:nvSpPr>
+        <p:spPr/>
+      </p:sp>
+    </p:spTree>
+  </p:cSld>
+  <p:clrMapOvr>
+    <a:masterClrMapping/>
+  </p:clrMapOvr>
+</p:notes>
+</file>
+
+<file path=ppt/notesSlides/notesSlide2.xml><?xml version="1.0" encoding="utf-8"?>
+<p:notes xmlns:a="http://schemas.openxmlformats.org/drawingml/2006/main" xmlns:p="http://schemas.openxmlformats.org/presentationml/2006/main" xmlns:r="http://schemas.openxmlformats.org/officeDocument/2006/relationships">
+  <p:cSld>
+    <p:spTree>
+      <p:nvGrpSpPr>
+        <p:cNvPr id="1" name=""/>
+        <p:cNvGrpSpPr/>
+        <p:nvPr/>
+      </p:nvGrpSpPr>
+      <p:grpSpPr>
+        <a:xfrm>
+          <a:off x="0" y="0"/>
+          <a:ext cx="0" cy="0"/>
+          <a:chOff x="0" y="0"/>
+          <a:chExt cx="0" cy="0"/>
+        </a:xfrm>
+      </p:grpSpPr>
+      <p:sp>
+        <p:nvSpPr>
+          <p:cNvPr id="2" name="Slide Image Placeholder 1"/>
+          <p:cNvSpPr>
+            <a:spLocks noGrp="1"/>
+          </p:cNvSpPr>
+          <p:nvPr>
+            <p:ph type="sldImg" idx="2"/>
+          </p:nvPr>
+        </p:nvSpPr>
+        <p:spPr/>
+      </p:sp>
+      <p:sp>
+        <p:nvSpPr>
+          <p:cNvPr id="3" name="Notes Placeholder 2"/>
+          <p:cNvSpPr>
+            <a:spLocks noGrp="1"/>
+          </p:cNvSpPr>
+          <p:nvPr>
+            <p:ph type="body" idx="3" sz="quarter"/>
+          </p:nvPr>
+        </p:nvSpPr>
+        <p:spPr/>
+        <p:txBody>
+          <a:bodyPr/>
+          <a:lstStyle/>
+          <a:p>
+            <a:r>
+              <a:t>"This is the chain. Structural conditions in the operation — how authority works, how mistakes get handled, how much certainty people have about what's expected — shape how managers experience their environment day to day. That shapes how managers show up with their teams. That shapes how employees experience their environment. And what you see is in the fourth box: the conflict, the avoidance, the turnover. The fifth box is what it costs you. You're watching the last two boxes. The work is in the first three."</a:t>
+            </a:r>
+          </a:p>
+          <a:p/>
+          <a:p>
+            <a:r>
+              <a:t>Deploy when: Owner asks HOW environment produces behavior; OR after a specific incident</a:t>
+            </a:r>
+          </a:p>
+          <a:p>
+            <a:r>
+              <a:t>Duration: 75–90 seconds</a:t>
+            </a:r>
+          </a:p>
+          <a:p>
+            <a:r>
+              <a:t>Put away when: Owner can place what he described in the chain</a:t>
+            </a:r>
+          </a:p>
+        </p:txBody>
+      </p:sp>
+      <p:sp>
+        <p:nvSpPr>
+          <p:cNvPr id="4" name="Slide Number Placeholder 3"/>
+          <p:cNvSpPr>
+            <a:spLocks noGrp="1"/>
+          </p:cNvSpPr>
+          <p:nvPr>
+            <p:ph type="sldNum" idx="5" sz="quarter"/>
+          </p:nvPr>
+        </p:nvSpPr>
+        <p:spPr/>
+      </p:sp>
+    </p:spTree>
+  </p:cSld>
+  <p:clrMapOvr>
+    <a:masterClrMapping/>
+  </p:clrMapOvr>
+</p:notes>
+</file>
+
+<file path=ppt/notesSlides/notesSlide3.xml><?xml version="1.0" encoding="utf-8"?>
+<p:notes xmlns:a="http://schemas.openxmlformats.org/drawingml/2006/main" xmlns:p="http://schemas.openxmlformats.org/presentationml/2006/main" xmlns:r="http://schemas.openxmlformats.org/officeDocument/2006/relationships">
+  <p:cSld>
+    <p:spTree>
+      <p:nvGrpSpPr>
+        <p:cNvPr id="1" name=""/>
+        <p:cNvGrpSpPr/>
+        <p:nvPr/>
+      </p:nvGrpSpPr>
+      <p:grpSpPr>
+        <a:xfrm>
+          <a:off x="0" y="0"/>
+          <a:ext cx="0" cy="0"/>
+          <a:chOff x="0" y="0"/>
+          <a:chExt cx="0" cy="0"/>
+        </a:xfrm>
+      </p:grpSpPr>
+      <p:sp>
+        <p:nvSpPr>
+          <p:cNvPr id="2" name="Slide Image Placeholder 1"/>
+          <p:cNvSpPr>
+            <a:spLocks noGrp="1"/>
+          </p:cNvSpPr>
+          <p:nvPr>
+            <p:ph type="sldImg" idx="2"/>
+          </p:nvPr>
+        </p:nvSpPr>
+        <p:spPr/>
+      </p:sp>
+      <p:sp>
+        <p:nvSpPr>
+          <p:cNvPr id="3" name="Notes Placeholder 2"/>
+          <p:cNvSpPr>
+            <a:spLocks noGrp="1"/>
+          </p:cNvSpPr>
+          <p:nvPr>
+            <p:ph type="body" idx="3" sz="quarter"/>
+          </p:nvPr>
+        </p:nvSpPr>
+        <p:spPr/>
+        <p:txBody>
+          <a:bodyPr/>
+          <a:lstStyle/>
+          <a:p>
+            <a:r>
+              <a:t>"At your scale, you're replacing roughly 300 people a year. At $3,000 to $5,000 per replacement — and those are conservative numbers for hospitality — that's $1.2 million annually, just in replacement cost. That doesn't count what it costs while the position is vacant, what it costs to ramp a new hire, or what it costs to your guest experience when your team is in constant turnover. The Phase 1 investment is $28,000. That pays for itself before you'd notice the savings."</a:t>
+            </a:r>
+          </a:p>
+          <a:p/>
+          <a:p>
+            <a:r>
+              <a:t>Deploy when: Owner raises cost or asks about pricing; OR making the investment case before Phase 1</a:t>
+            </a:r>
+          </a:p>
+          <a:p>
+            <a:r>
+              <a:t>Duration: 60 seconds</a:t>
+            </a:r>
+          </a:p>
+          <a:p>
+            <a:r>
+              <a:t>Put away when: Owner has reacted to the numbers</a:t>
+            </a:r>
+          </a:p>
+        </p:txBody>
+      </p:sp>
+      <p:sp>
+        <p:nvSpPr>
+          <p:cNvPr id="4" name="Slide Number Placeholder 3"/>
+          <p:cNvSpPr>
+            <a:spLocks noGrp="1"/>
+          </p:cNvSpPr>
+          <p:nvPr>
+            <p:ph type="sldNum" idx="5" sz="quarter"/>
+          </p:nvPr>
+        </p:nvSpPr>
+        <p:spPr/>
+      </p:sp>
+    </p:spTree>
+  </p:cSld>
+  <p:clrMapOvr>
+    <a:masterClrMapping/>
+  </p:clrMapOvr>
+</p:notes>
+</file>
+
+<file path=ppt/notesSlides/notesSlide4.xml><?xml version="1.0" encoding="utf-8"?>
+<p:notes xmlns:a="http://schemas.openxmlformats.org/drawingml/2006/main" xmlns:p="http://schemas.openxmlformats.org/presentationml/2006/main" xmlns:r="http://schemas.openxmlformats.org/officeDocument/2006/relationships">
+  <p:cSld>
+    <p:spTree>
+      <p:nvGrpSpPr>
+        <p:cNvPr id="1" name=""/>
+        <p:cNvGrpSpPr/>
+        <p:nvPr/>
+      </p:nvGrpSpPr>
+      <p:grpSpPr>
+        <a:xfrm>
+          <a:off x="0" y="0"/>
+          <a:ext cx="0" cy="0"/>
+          <a:chOff x="0" y="0"/>
+          <a:chExt cx="0" cy="0"/>
+        </a:xfrm>
+      </p:grpSpPr>
+      <p:sp>
+        <p:nvSpPr>
+          <p:cNvPr id="2" name="Slide Image Placeholder 1"/>
+          <p:cNvSpPr>
+            <a:spLocks noGrp="1"/>
+          </p:cNvSpPr>
+          <p:nvPr>
+            <p:ph type="sldImg" idx="2"/>
+          </p:nvPr>
+        </p:nvSpPr>
+        <p:spPr/>
+      </p:sp>
+      <p:sp>
+        <p:nvSpPr>
+          <p:cNvPr id="3" name="Notes Placeholder 2"/>
+          <p:cNvSpPr>
+            <a:spLocks noGrp="1"/>
+          </p:cNvSpPr>
+          <p:nvPr>
+            <p:ph type="body" idx="3" sz="quarter"/>
+          </p:nvPr>
+        </p:nvSpPr>
+        <p:spPr/>
+        <p:txBody>
+          <a:bodyPr/>
+          <a:lstStyle/>
+          <a:p>
+            <a:r>
+              <a:t>"Three things come out of Phase 1. First, a behavioral profile for each leader — what their patterns are, what activates them, and what their specific development path looks like. Second, a team map — how the management team functions collectively, and what in the structure is contributing to the patterns. Third, structural recommendations — specific things in how you're running the environment that are driving what you're seeing. Each one connects to a specific decision. At the end of Phase 1 you decide whether you want to move to implementation."</a:t>
+            </a:r>
+          </a:p>
+          <a:p/>
+          <a:p>
+            <a:r>
+              <a:t>Deploy when: Owner asks "what do I actually get?" or "what are the deliverables?"</a:t>
+            </a:r>
+          </a:p>
+          <a:p>
+            <a:r>
+              <a:t>Duration: 75 seconds</a:t>
+            </a:r>
+          </a:p>
+          <a:p>
+            <a:r>
+              <a:t>Put away when: Owner has processed all three boxes</a:t>
+            </a:r>
+          </a:p>
+        </p:txBody>
+      </p:sp>
+      <p:sp>
+        <p:nvSpPr>
+          <p:cNvPr id="4" name="Slide Number Placeholder 3"/>
+          <p:cNvSpPr>
+            <a:spLocks noGrp="1"/>
+          </p:cNvSpPr>
+          <p:nvPr>
+            <p:ph type="sldNum" idx="5" sz="quarter"/>
+          </p:nvPr>
+        </p:nvSpPr>
+        <p:spPr/>
+      </p:sp>
+    </p:spTree>
+  </p:cSld>
+  <p:clrMapOvr>
+    <a:masterClrMapping/>
+  </p:clrMapOvr>
+</p:notes>
+</file>
+
+<file path=ppt/notesSlides/notesSlide5.xml><?xml version="1.0" encoding="utf-8"?>
+<p:notes xmlns:a="http://schemas.openxmlformats.org/drawingml/2006/main" xmlns:p="http://schemas.openxmlformats.org/presentationml/2006/main" xmlns:r="http://schemas.openxmlformats.org/officeDocument/2006/relationships">
+  <p:cSld>
+    <p:spTree>
+      <p:nvGrpSpPr>
+        <p:cNvPr id="1" name=""/>
+        <p:cNvGrpSpPr/>
+        <p:nvPr/>
+      </p:nvGrpSpPr>
+      <p:grpSpPr>
+        <a:xfrm>
+          <a:off x="0" y="0"/>
+          <a:ext cx="0" cy="0"/>
+          <a:chOff x="0" y="0"/>
+          <a:chExt cx="0" cy="0"/>
+        </a:xfrm>
+      </p:grpSpPr>
+      <p:sp>
+        <p:nvSpPr>
+          <p:cNvPr id="2" name="Slide Image Placeholder 1"/>
+          <p:cNvSpPr>
+            <a:spLocks noGrp="1"/>
+          </p:cNvSpPr>
+          <p:nvPr>
+            <p:ph type="sldImg" idx="2"/>
+          </p:nvPr>
+        </p:nvSpPr>
+        <p:spPr/>
+      </p:sp>
+      <p:sp>
+        <p:nvSpPr>
+          <p:cNvPr id="3" name="Notes Placeholder 2"/>
+          <p:cNvSpPr>
+            <a:spLocks noGrp="1"/>
+          </p:cNvSpPr>
+          <p:nvPr>
+            <p:ph type="body" idx="3" sz="quarter"/>
+          </p:nvPr>
+        </p:nvSpPr>
+        <p:spPr/>
+        <p:txBody>
+          <a:bodyPr/>
+          <a:lstStyle/>
+          <a:p>
+            <a:r>
+              <a:t>"Phase 1 is 13 weeks — assessment, interpretation, debrief. The first things you'll notice if we proceed to implementation are behavioral — your managers showing up differently in difficult situations. That typically happens within 60 to 90 days of well-implemented development work. The turnover shift follows, at 6 to 12 months. A culture that holds without you having to maintain it manually — that's 18 months or more. I'm not going to tell you this is fast. What I will tell you is that you've already seen what not doing it costs."</a:t>
+            </a:r>
+          </a:p>
+          <a:p/>
+          <a:p>
+            <a:r>
+              <a:t>Deploy when: Owner asks "how long before I see a difference?" or expresses timeline pressure</a:t>
+            </a:r>
+          </a:p>
+          <a:p>
+            <a:r>
+              <a:t>Duration: 75 seconds</a:t>
+            </a:r>
+          </a:p>
+          <a:p>
+            <a:r>
+              <a:t>Put away when: Owner acknowledges the timeline</a:t>
+            </a:r>
+          </a:p>
+        </p:txBody>
+      </p:sp>
+      <p:sp>
+        <p:nvSpPr>
+          <p:cNvPr id="4" name="Slide Number Placeholder 3"/>
+          <p:cNvSpPr>
+            <a:spLocks noGrp="1"/>
+          </p:cNvSpPr>
+          <p:nvPr>
+            <p:ph type="sldNum" idx="5" sz="quarter"/>
+          </p:nvPr>
+        </p:nvSpPr>
+        <p:spPr/>
+      </p:sp>
+    </p:spTree>
+  </p:cSld>
+  <p:clrMapOvr>
+    <a:masterClrMapping/>
+  </p:clrMapOvr>
+</p:notes>
+</file>
+
+<file path=ppt/notesSlides/notesSlide6.xml><?xml version="1.0" encoding="utf-8"?>
+<p:notes xmlns:a="http://schemas.openxmlformats.org/drawingml/2006/main" xmlns:p="http://schemas.openxmlformats.org/presentationml/2006/main" xmlns:r="http://schemas.openxmlformats.org/officeDocument/2006/relationships">
+  <p:cSld>
+    <p:spTree>
+      <p:nvGrpSpPr>
+        <p:cNvPr id="1" name=""/>
+        <p:cNvGrpSpPr/>
+        <p:nvPr/>
+      </p:nvGrpSpPr>
+      <p:grpSpPr>
+        <a:xfrm>
+          <a:off x="0" y="0"/>
+          <a:ext cx="0" cy="0"/>
+          <a:chOff x="0" y="0"/>
+          <a:chExt cx="0" cy="0"/>
+        </a:xfrm>
+      </p:grpSpPr>
+      <p:sp>
+        <p:nvSpPr>
+          <p:cNvPr id="2" name="Slide Image Placeholder 1"/>
+          <p:cNvSpPr>
+            <a:spLocks noGrp="1"/>
+          </p:cNvSpPr>
+          <p:nvPr>
+            <p:ph type="sldImg" idx="2"/>
+          </p:nvPr>
+        </p:nvSpPr>
+        <p:spPr/>
+      </p:sp>
+      <p:sp>
+        <p:nvSpPr>
+          <p:cNvPr id="3" name="Notes Placeholder 2"/>
+          <p:cNvSpPr>
+            <a:spLocks noGrp="1"/>
+          </p:cNvSpPr>
+          <p:nvPr>
+            <p:ph type="body" idx="3" sz="quarter"/>
+          </p:nvPr>
+        </p:nvSpPr>
+        <p:spPr/>
+        <p:txBody>
+          <a:bodyPr/>
+          <a:lstStyle/>
+          <a:p>
+            <a:r>
+              <a:t>"Before you meet with your managers about this — here's the frame that will set things up well for you. The thing your OMs will want to know first is what this means for them — whether they're being evaluated, whether you'll have access to what they share, whether this is being done to them or with them. The confidentiality structure means their individual data stays with them — what you receive is the aggregate picture. That protection is what makes honest assessment possible. Your managers are not the problem here. They're the lever."</a:t>
+            </a:r>
+          </a:p>
+          <a:p/>
+          <a:p>
+            <a:r>
+              <a:t>Deploy when: Close of meeting — owner surfaces OM question; OR Pivot 2 is raised</a:t>
+            </a:r>
+          </a:p>
+          <a:p>
+            <a:r>
+              <a:t>Duration: 75–90 seconds</a:t>
+            </a:r>
+          </a:p>
+          <a:p>
+            <a:r>
+              <a:t>Put away when: Owner has language for how to introduce Andrew to OMs</a:t>
+            </a:r>
+          </a:p>
+        </p:txBody>
+      </p:sp>
+      <p:sp>
+        <p:nvSpPr>
+          <p:cNvPr id="4" name="Slide Number Placeholder 3"/>
+          <p:cNvSpPr>
+            <a:spLocks noGrp="1"/>
+          </p:cNvSpPr>
+          <p:nvPr>
+            <p:ph type="sldNum" idx="5" sz="quarter"/>
+          </p:nvPr>
+        </p:nvSpPr>
+        <p:spPr/>
+      </p:sp>
+    </p:spTree>
+  </p:cSld>
+  <p:clrMapOvr>
+    <a:masterClrMapping/>
+  </p:clrMapOvr>
+</p:notes>
 </file>
 
 <file path=ppt/slideLayouts/slideLayout1.xml><?xml version="1.0" encoding="utf-8"?>
@@ -3103,125 +3969,20 @@
       <p:grpSpPr/>
       <p:sp>
         <p:nvSpPr>
-          <p:cNvPr id="2" name="TextBox 1"/>
-          <p:cNvSpPr txBox="1"/>
-          <p:nvPr/>
-        </p:nvSpPr>
-        <p:spPr>
-          <a:xfrm>
-            <a:off x="201168" y="91440"/>
-            <a:ext cx="502920" cy="274320"/>
-          </a:xfrm>
-          <a:prstGeom prst="rect">
-            <a:avLst/>
-          </a:prstGeom>
-          <a:noFill/>
-        </p:spPr>
-        <p:txBody>
-          <a:bodyPr wrap="square">
-            <a:spAutoFit/>
-          </a:bodyPr>
-          <a:lstStyle/>
-          <a:p>
-            <a:pPr algn="l"/>
-            <a:r>
-              <a:rPr sz="1300" b="1" i="0">
-                <a:solidFill>
-                  <a:srgbClr val="2E7D87"/>
-                </a:solidFill>
-                <a:latin typeface="Calibri"/>
-              </a:rPr>
-              <a:t>01</a:t>
-            </a:r>
-          </a:p>
-        </p:txBody>
-      </p:sp>
-      <p:sp>
-        <p:nvSpPr>
-          <p:cNvPr id="3" name="TextBox 2"/>
-          <p:cNvSpPr txBox="1"/>
-          <p:nvPr/>
-        </p:nvSpPr>
-        <p:spPr>
-          <a:xfrm>
-            <a:off x="502920" y="228600"/>
-            <a:ext cx="5303520" cy="530352"/>
-          </a:xfrm>
-          <a:prstGeom prst="rect">
-            <a:avLst/>
-          </a:prstGeom>
-          <a:noFill/>
-        </p:spPr>
-        <p:txBody>
-          <a:bodyPr wrap="square">
-            <a:spAutoFit/>
-          </a:bodyPr>
-          <a:lstStyle/>
-          <a:p>
-            <a:pPr algn="ctr"/>
-            <a:r>
-              <a:rPr sz="2800" b="1" i="0">
-                <a:solidFill>
-                  <a:srgbClr val="2E7D87"/>
-                </a:solidFill>
-                <a:latin typeface="Calibri"/>
-              </a:rPr>
-              <a:t>STANDARD APPROACH</a:t>
-            </a:r>
-          </a:p>
-        </p:txBody>
-      </p:sp>
-      <p:sp>
-        <p:nvSpPr>
-          <p:cNvPr id="4" name="TextBox 3"/>
-          <p:cNvSpPr txBox="1"/>
-          <p:nvPr/>
-        </p:nvSpPr>
-        <p:spPr>
-          <a:xfrm>
-            <a:off x="6446520" y="228600"/>
-            <a:ext cx="5303520" cy="530352"/>
-          </a:xfrm>
-          <a:prstGeom prst="rect">
-            <a:avLst/>
-          </a:prstGeom>
-          <a:noFill/>
-        </p:spPr>
-        <p:txBody>
-          <a:bodyPr wrap="square">
-            <a:spAutoFit/>
-          </a:bodyPr>
-          <a:lstStyle/>
-          <a:p>
-            <a:pPr algn="ctr"/>
-            <a:r>
-              <a:rPr sz="2800" b="1" i="0">
-                <a:solidFill>
-                  <a:srgbClr val="2E7D87"/>
-                </a:solidFill>
-                <a:latin typeface="Calibri"/>
-              </a:rPr>
-              <a:t>WHAT'S DIFFERENT HERE</a:t>
-            </a:r>
-          </a:p>
-        </p:txBody>
-      </p:sp>
-      <p:sp>
-        <p:nvSpPr>
-          <p:cNvPr id="5" name="Rectangle 4"/>
+          <p:cNvPr id="2" name="Rectangle 1"/>
           <p:cNvSpPr/>
           <p:nvPr/>
         </p:nvSpPr>
         <p:spPr>
           <a:xfrm>
-            <a:off x="5925312" y="137160"/>
-            <a:ext cx="36576" cy="6492240"/>
+            <a:off x="6094476" y="822960"/>
+            <a:ext cx="22860" cy="4572000"/>
           </a:xfrm>
           <a:prstGeom prst="rect">
             <a:avLst/>
           </a:prstGeom>
           <a:solidFill>
-            <a:srgbClr val="2E7D87"/>
+            <a:srgbClr val="CCCCCC"/>
           </a:solidFill>
           <a:ln>
             <a:noFill/>
@@ -3251,57 +4012,22 @@
       </p:sp>
       <p:sp>
         <p:nvSpPr>
-          <p:cNvPr id="6" name="TextBox 5"/>
-          <p:cNvSpPr txBox="1"/>
-          <p:nvPr/>
-        </p:nvSpPr>
-        <p:spPr>
-          <a:xfrm>
-            <a:off x="5257800" y="2788920"/>
-            <a:ext cx="1444752" cy="594360"/>
-          </a:xfrm>
-          <a:prstGeom prst="rect">
-            <a:avLst/>
-          </a:prstGeom>
-          <a:noFill/>
-        </p:spPr>
-        <p:txBody>
-          <a:bodyPr wrap="square">
-            <a:spAutoFit/>
-          </a:bodyPr>
-          <a:lstStyle/>
-          <a:p>
-            <a:pPr algn="ctr"/>
-            <a:r>
-              <a:rPr sz="4400" b="1" i="0">
-                <a:solidFill>
-                  <a:srgbClr val="2E7D87"/>
-                </a:solidFill>
-                <a:latin typeface="Calibri"/>
-              </a:rPr>
-              <a:t>→</a:t>
-            </a:r>
-          </a:p>
-        </p:txBody>
-      </p:sp>
-      <p:sp>
-        <p:nvSpPr>
-          <p:cNvPr id="7" name="Rectangle 6"/>
+          <p:cNvPr id="3" name="Can 2"/>
           <p:cNvSpPr/>
           <p:nvPr/>
         </p:nvSpPr>
         <p:spPr>
           <a:xfrm>
-            <a:off x="502920" y="896112"/>
-            <a:ext cx="5212080" cy="5230368"/>
-          </a:xfrm>
-          <a:prstGeom prst="rect">
+            <a:off x="5641848" y="3017520"/>
+            <a:ext cx="905256" cy="411480"/>
+          </a:xfrm>
+          <a:prstGeom prst="can">
             <a:avLst/>
           </a:prstGeom>
           <a:solidFill>
-            <a:srgbClr val="FFFFFF"/>
+            <a:srgbClr val="2E7D87"/>
           </a:solidFill>
-          <a:ln w="25400">
+          <a:ln>
             <a:solidFill>
               <a:srgbClr val="2E7D87"/>
             </a:solidFill>
@@ -3322,302 +4048,23 @@
           </a:fontRef>
         </p:style>
         <p:txBody>
-          <a:bodyPr rtlCol="0" anchor="ctr" wrap="square"/>
-          <a:lstStyle/>
-          <a:p>
-            <a:pPr algn="ctr"/>
-            <a:r>
-              <a:rPr sz="2400" b="0" i="0">
-                <a:solidFill>
-                  <a:srgbClr val="1A2744"/>
-                </a:solidFill>
-                <a:latin typeface="Calibri"/>
-              </a:rPr>
-              <a:t>Changes knowledge</a:t>
-            </a:r>
-          </a:p>
-          <a:p>
-            <a:pPr algn="ctr"/>
-            <a:r>
-              <a:rPr sz="800" b="0" i="0">
-                <a:solidFill>
-                  <a:srgbClr val="1A2744"/>
-                </a:solidFill>
-                <a:latin typeface="Calibri"/>
-              </a:rPr>
-              <a:t/>
-            </a:r>
-          </a:p>
-          <a:p>
-            <a:pPr algn="ctr"/>
-            <a:r>
-              <a:rPr sz="3000" b="0" i="0">
-                <a:solidFill>
-                  <a:srgbClr val="1A2744"/>
-                </a:solidFill>
-                <a:latin typeface="Calibri"/>
-              </a:rPr>
-              <a:t>↓</a:t>
-            </a:r>
-          </a:p>
-          <a:p>
-            <a:pPr algn="ctr"/>
-            <a:r>
-              <a:rPr sz="800" b="0" i="0">
-                <a:solidFill>
-                  <a:srgbClr val="1A2744"/>
-                </a:solidFill>
-                <a:latin typeface="Calibri"/>
-              </a:rPr>
-              <a:t/>
-            </a:r>
-          </a:p>
-          <a:p>
-            <a:pPr algn="ctr"/>
-            <a:r>
-              <a:rPr sz="2400" b="0" i="0">
-                <a:solidFill>
-                  <a:srgbClr val="1A2744"/>
-                </a:solidFill>
-                <a:latin typeface="Calibri"/>
-              </a:rPr>
-              <a:t>Doesn't reach what</a:t>
-            </a:r>
-          </a:p>
-          <a:p>
-            <a:pPr algn="ctr"/>
-            <a:r>
-              <a:rPr sz="2400" b="0" i="0">
-                <a:solidFill>
-                  <a:srgbClr val="1A2744"/>
-                </a:solidFill>
-                <a:latin typeface="Calibri"/>
-              </a:rPr>
-              <a:t>produces the behavior</a:t>
-            </a:r>
-          </a:p>
-          <a:p>
-            <a:pPr algn="ctr"/>
-            <a:r>
-              <a:rPr sz="800" b="0" i="0">
-                <a:solidFill>
-                  <a:srgbClr val="1A2744"/>
-                </a:solidFill>
-                <a:latin typeface="Calibri"/>
-              </a:rPr>
-              <a:t/>
-            </a:r>
-          </a:p>
-          <a:p>
-            <a:pPr algn="ctr"/>
-            <a:r>
-              <a:rPr sz="3000" b="0" i="0">
-                <a:solidFill>
-                  <a:srgbClr val="1A2744"/>
-                </a:solidFill>
-                <a:latin typeface="Calibri"/>
-              </a:rPr>
-              <a:t>↓</a:t>
-            </a:r>
-          </a:p>
-          <a:p>
-            <a:pPr algn="ctr"/>
-            <a:r>
-              <a:rPr sz="800" b="0" i="0">
-                <a:solidFill>
-                  <a:srgbClr val="1A2744"/>
-                </a:solidFill>
-                <a:latin typeface="Calibri"/>
-              </a:rPr>
-              <a:t/>
-            </a:r>
-          </a:p>
-          <a:p>
-            <a:pPr algn="ctr"/>
-            <a:r>
-              <a:rPr sz="2400" b="0" i="0">
-                <a:solidFill>
-                  <a:srgbClr val="1A2744"/>
-                </a:solidFill>
-                <a:latin typeface="Calibri"/>
-              </a:rPr>
-              <a:t>Reverts in 30–90 days</a:t>
-            </a:r>
-          </a:p>
-        </p:txBody>
-      </p:sp>
-      <p:sp>
-        <p:nvSpPr>
-          <p:cNvPr id="8" name="Rectangle 7"/>
-          <p:cNvSpPr/>
-          <p:nvPr/>
-        </p:nvSpPr>
-        <p:spPr>
-          <a:xfrm>
-            <a:off x="6446520" y="896112"/>
-            <a:ext cx="5212080" cy="5230368"/>
-          </a:xfrm>
-          <a:prstGeom prst="rect">
-            <a:avLst/>
-          </a:prstGeom>
-          <a:solidFill>
-            <a:srgbClr val="FFFFFF"/>
-          </a:solidFill>
-          <a:ln w="25400">
-            <a:solidFill>
-              <a:srgbClr val="2E7D87"/>
-            </a:solidFill>
-          </a:ln>
-        </p:spPr>
-        <p:style>
-          <a:lnRef idx="1">
-            <a:schemeClr val="accent1"/>
-          </a:lnRef>
-          <a:fillRef idx="3">
-            <a:schemeClr val="accent1"/>
-          </a:fillRef>
-          <a:effectRef idx="2">
-            <a:schemeClr val="accent1"/>
-          </a:effectRef>
-          <a:fontRef idx="minor">
-            <a:schemeClr val="lt1"/>
-          </a:fontRef>
-        </p:style>
-        <p:txBody>
-          <a:bodyPr rtlCol="0" anchor="ctr" wrap="square"/>
-          <a:lstStyle/>
-          <a:p>
-            <a:pPr algn="ctr"/>
-            <a:r>
-              <a:rPr sz="2400" b="0" i="0">
-                <a:solidFill>
-                  <a:srgbClr val="1A2744"/>
-                </a:solidFill>
-                <a:latin typeface="Calibri"/>
-              </a:rPr>
-              <a:t>Changes conditions</a:t>
-            </a:r>
-          </a:p>
-          <a:p>
-            <a:pPr algn="ctr"/>
-            <a:r>
-              <a:rPr sz="800" b="0" i="0">
-                <a:solidFill>
-                  <a:srgbClr val="1A2744"/>
-                </a:solidFill>
-                <a:latin typeface="Calibri"/>
-              </a:rPr>
-              <a:t/>
-            </a:r>
-          </a:p>
-          <a:p>
-            <a:pPr algn="ctr"/>
-            <a:r>
-              <a:rPr sz="3000" b="0" i="0">
-                <a:solidFill>
-                  <a:srgbClr val="1A2744"/>
-                </a:solidFill>
-                <a:latin typeface="Calibri"/>
-              </a:rPr>
-              <a:t>↓</a:t>
-            </a:r>
-          </a:p>
-          <a:p>
-            <a:pPr algn="ctr"/>
-            <a:r>
-              <a:rPr sz="800" b="0" i="0">
-                <a:solidFill>
-                  <a:srgbClr val="1A2744"/>
-                </a:solidFill>
-                <a:latin typeface="Calibri"/>
-              </a:rPr>
-              <a:t/>
-            </a:r>
-          </a:p>
-          <a:p>
-            <a:pPr algn="ctr"/>
-            <a:r>
-              <a:rPr sz="2400" b="0" i="0">
-                <a:solidFill>
-                  <a:srgbClr val="1A2744"/>
-                </a:solidFill>
-                <a:latin typeface="Calibri"/>
-              </a:rPr>
-              <a:t>Addresses what</a:t>
-            </a:r>
-          </a:p>
-          <a:p>
-            <a:pPr algn="ctr"/>
-            <a:r>
-              <a:rPr sz="2400" b="0" i="0">
-                <a:solidFill>
-                  <a:srgbClr val="1A2744"/>
-                </a:solidFill>
-                <a:latin typeface="Calibri"/>
-              </a:rPr>
-              <a:t>produces the behavior</a:t>
-            </a:r>
-          </a:p>
-          <a:p>
-            <a:pPr algn="ctr"/>
-            <a:r>
-              <a:rPr sz="800" b="0" i="0">
-                <a:solidFill>
-                  <a:srgbClr val="1A2744"/>
-                </a:solidFill>
-                <a:latin typeface="Calibri"/>
-              </a:rPr>
-              <a:t/>
-            </a:r>
-          </a:p>
-          <a:p>
-            <a:pPr algn="ctr"/>
-            <a:r>
-              <a:rPr sz="3000" b="0" i="0">
-                <a:solidFill>
-                  <a:srgbClr val="1A2744"/>
-                </a:solidFill>
-                <a:latin typeface="Calibri"/>
-              </a:rPr>
-              <a:t>↓</a:t>
-            </a:r>
-          </a:p>
-          <a:p>
-            <a:pPr algn="ctr"/>
-            <a:r>
-              <a:rPr sz="800" b="0" i="0">
-                <a:solidFill>
-                  <a:srgbClr val="1A2744"/>
-                </a:solidFill>
-                <a:latin typeface="Calibri"/>
-              </a:rPr>
-              <a:t/>
-            </a:r>
-          </a:p>
-          <a:p>
-            <a:pPr algn="ctr"/>
-            <a:r>
-              <a:rPr sz="2400" b="0" i="0">
-                <a:solidFill>
-                  <a:srgbClr val="1A2744"/>
-                </a:solidFill>
-                <a:latin typeface="Calibri"/>
-              </a:rPr>
-              <a:t>Holds</a:t>
-            </a:r>
-          </a:p>
-        </p:txBody>
-      </p:sp>
-      <p:sp>
-        <p:nvSpPr>
-          <p:cNvPr id="9" name="TextBox 8"/>
+          <a:bodyPr rtlCol="0" anchor="ctr"/>
+          <a:lstStyle/>
+          <a:p>
+            <a:pPr algn="ctr"/>
+          </a:p>
+        </p:txBody>
+      </p:sp>
+      <p:sp>
+        <p:nvSpPr>
+          <p:cNvPr id="4" name="TextBox 3"/>
           <p:cNvSpPr txBox="1"/>
           <p:nvPr/>
         </p:nvSpPr>
         <p:spPr>
           <a:xfrm>
-            <a:off x="365760" y="6263640"/>
-            <a:ext cx="11430000" cy="438912"/>
+            <a:off x="457200" y="822960"/>
+            <a:ext cx="5029200" cy="502920"/>
           </a:xfrm>
           <a:prstGeom prst="rect">
             <a:avLst/>
@@ -3632,13 +4079,249 @@
           <a:p>
             <a:pPr algn="ctr"/>
             <a:r>
-              <a:rPr sz="1800" b="0" i="1">
+              <a:rPr sz="2600" b="1" i="0">
                 <a:solidFill>
                   <a:srgbClr val="1A2744"/>
                 </a:solidFill>
                 <a:latin typeface="Calibri"/>
               </a:rPr>
-              <a:t>The pattern is produced by the environment. Standard training doesn’t touch the environment.</a:t>
+              <a:t>STANDARD APPROACH</a:t>
+            </a:r>
+          </a:p>
+        </p:txBody>
+      </p:sp>
+      <p:sp>
+        <p:nvSpPr>
+          <p:cNvPr id="5" name="TextBox 4"/>
+          <p:cNvSpPr txBox="1"/>
+          <p:nvPr/>
+        </p:nvSpPr>
+        <p:spPr>
+          <a:xfrm>
+            <a:off x="457200" y="1463040"/>
+            <a:ext cx="5029200" cy="3840480"/>
+          </a:xfrm>
+          <a:prstGeom prst="rect">
+            <a:avLst/>
+          </a:prstGeom>
+          <a:noFill/>
+        </p:spPr>
+        <p:txBody>
+          <a:bodyPr wrap="square">
+            <a:spAutoFit/>
+          </a:bodyPr>
+          <a:lstStyle/>
+          <a:p>
+            <a:pPr algn="ctr"/>
+            <a:r>
+              <a:rPr sz="2200" b="0" i="0">
+                <a:solidFill>
+                  <a:srgbClr val="1A2744"/>
+                </a:solidFill>
+                <a:latin typeface="Calibri"/>
+              </a:rPr>
+              <a:t>Changes knowledge</a:t>
+            </a:r>
+          </a:p>
+          <a:p>
+            <a:pPr algn="ctr"/>
+            <a:r>
+              <a:rPr sz="2200" b="0" i="0">
+                <a:solidFill>
+                  <a:srgbClr val="1A2744"/>
+                </a:solidFill>
+                <a:latin typeface="Calibri"/>
+              </a:rPr>
+              <a:t>↓</a:t>
+            </a:r>
+          </a:p>
+          <a:p>
+            <a:pPr algn="ctr"/>
+            <a:r>
+              <a:rPr sz="2200" b="0" i="0">
+                <a:solidFill>
+                  <a:srgbClr val="1A2744"/>
+                </a:solidFill>
+                <a:latin typeface="Calibri"/>
+              </a:rPr>
+              <a:t>Doesn't reach what produces the behavior</a:t>
+            </a:r>
+          </a:p>
+          <a:p>
+            <a:pPr algn="ctr"/>
+            <a:r>
+              <a:rPr sz="2200" b="0" i="0">
+                <a:solidFill>
+                  <a:srgbClr val="1A2744"/>
+                </a:solidFill>
+                <a:latin typeface="Calibri"/>
+              </a:rPr>
+              <a:t>↓</a:t>
+            </a:r>
+          </a:p>
+          <a:p>
+            <a:pPr algn="ctr"/>
+            <a:r>
+              <a:rPr sz="2200" b="0" i="0">
+                <a:solidFill>
+                  <a:srgbClr val="1A2744"/>
+                </a:solidFill>
+                <a:latin typeface="Calibri"/>
+              </a:rPr>
+              <a:t>Reverts in 30–90 days</a:t>
+            </a:r>
+          </a:p>
+        </p:txBody>
+      </p:sp>
+      <p:sp>
+        <p:nvSpPr>
+          <p:cNvPr id="6" name="TextBox 5"/>
+          <p:cNvSpPr txBox="1"/>
+          <p:nvPr/>
+        </p:nvSpPr>
+        <p:spPr>
+          <a:xfrm>
+            <a:off x="6702552" y="822960"/>
+            <a:ext cx="5029200" cy="502920"/>
+          </a:xfrm>
+          <a:prstGeom prst="rect">
+            <a:avLst/>
+          </a:prstGeom>
+          <a:noFill/>
+        </p:spPr>
+        <p:txBody>
+          <a:bodyPr wrap="square">
+            <a:spAutoFit/>
+          </a:bodyPr>
+          <a:lstStyle/>
+          <a:p>
+            <a:pPr algn="ctr"/>
+            <a:r>
+              <a:rPr sz="2600" b="1" i="0">
+                <a:solidFill>
+                  <a:srgbClr val="1A2744"/>
+                </a:solidFill>
+                <a:latin typeface="Calibri"/>
+              </a:rPr>
+              <a:t>WHAT'S DIFFERENT HERE</a:t>
+            </a:r>
+          </a:p>
+        </p:txBody>
+      </p:sp>
+      <p:sp>
+        <p:nvSpPr>
+          <p:cNvPr id="7" name="TextBox 6"/>
+          <p:cNvSpPr txBox="1"/>
+          <p:nvPr/>
+        </p:nvSpPr>
+        <p:spPr>
+          <a:xfrm>
+            <a:off x="6702552" y="1463040"/>
+            <a:ext cx="5029200" cy="3840480"/>
+          </a:xfrm>
+          <a:prstGeom prst="rect">
+            <a:avLst/>
+          </a:prstGeom>
+          <a:noFill/>
+        </p:spPr>
+        <p:txBody>
+          <a:bodyPr wrap="square">
+            <a:spAutoFit/>
+          </a:bodyPr>
+          <a:lstStyle/>
+          <a:p>
+            <a:pPr algn="ctr"/>
+            <a:r>
+              <a:rPr sz="2200" b="0" i="0">
+                <a:solidFill>
+                  <a:srgbClr val="1A2744"/>
+                </a:solidFill>
+                <a:latin typeface="Calibri"/>
+              </a:rPr>
+              <a:t>Changes conditions</a:t>
+            </a:r>
+          </a:p>
+          <a:p>
+            <a:pPr algn="ctr"/>
+            <a:r>
+              <a:rPr sz="2200" b="0" i="0">
+                <a:solidFill>
+                  <a:srgbClr val="1A2744"/>
+                </a:solidFill>
+                <a:latin typeface="Calibri"/>
+              </a:rPr>
+              <a:t>↓</a:t>
+            </a:r>
+          </a:p>
+          <a:p>
+            <a:pPr algn="ctr"/>
+            <a:r>
+              <a:rPr sz="2200" b="0" i="0">
+                <a:solidFill>
+                  <a:srgbClr val="1A2744"/>
+                </a:solidFill>
+                <a:latin typeface="Calibri"/>
+              </a:rPr>
+              <a:t>Addresses what produces the behavior</a:t>
+            </a:r>
+          </a:p>
+          <a:p>
+            <a:pPr algn="ctr"/>
+            <a:r>
+              <a:rPr sz="2200" b="0" i="0">
+                <a:solidFill>
+                  <a:srgbClr val="1A2744"/>
+                </a:solidFill>
+                <a:latin typeface="Calibri"/>
+              </a:rPr>
+              <a:t>↓</a:t>
+            </a:r>
+          </a:p>
+          <a:p>
+            <a:pPr algn="ctr"/>
+            <a:r>
+              <a:rPr sz="2200" b="0" i="0">
+                <a:solidFill>
+                  <a:srgbClr val="1A2744"/>
+                </a:solidFill>
+                <a:latin typeface="Calibri"/>
+              </a:rPr>
+              <a:t>Holds</a:t>
+            </a:r>
+          </a:p>
+        </p:txBody>
+      </p:sp>
+      <p:sp>
+        <p:nvSpPr>
+          <p:cNvPr id="8" name="TextBox 7"/>
+          <p:cNvSpPr txBox="1"/>
+          <p:nvPr/>
+        </p:nvSpPr>
+        <p:spPr>
+          <a:xfrm>
+            <a:off x="457200" y="6080760"/>
+            <a:ext cx="11274552" cy="548640"/>
+          </a:xfrm>
+          <a:prstGeom prst="rect">
+            <a:avLst/>
+          </a:prstGeom>
+          <a:noFill/>
+        </p:spPr>
+        <p:txBody>
+          <a:bodyPr wrap="square">
+            <a:spAutoFit/>
+          </a:bodyPr>
+          <a:lstStyle/>
+          <a:p>
+            <a:pPr algn="ctr"/>
+            <a:r>
+              <a:rPr sz="1800" b="0" i="1">
+                <a:solidFill>
+                  <a:srgbClr val="1A2744"/>
+                </a:solidFill>
+                <a:latin typeface="Calibri"/>
+              </a:rPr>
+              <a:t>The pattern is produced by the environment. Standard training doesn't touch the environment.</a:t>
             </a:r>
           </a:p>
         </p:txBody>
@@ -3677,8 +4360,8 @@
         </p:nvSpPr>
         <p:spPr>
           <a:xfrm>
-            <a:off x="201168" y="91440"/>
-            <a:ext cx="502920" cy="274320"/>
+            <a:off x="457200" y="365760"/>
+            <a:ext cx="11274552" cy="594360"/>
           </a:xfrm>
           <a:prstGeom prst="rect">
             <a:avLst/>
@@ -3693,41 +4376,6 @@
           <a:p>
             <a:pPr algn="l"/>
             <a:r>
-              <a:rPr sz="1300" b="1" i="0">
-                <a:solidFill>
-                  <a:srgbClr val="2E7D87"/>
-                </a:solidFill>
-                <a:latin typeface="Calibri"/>
-              </a:rPr>
-              <a:t>02</a:t>
-            </a:r>
-          </a:p>
-        </p:txBody>
-      </p:sp>
-      <p:sp>
-        <p:nvSpPr>
-          <p:cNvPr id="3" name="TextBox 2"/>
-          <p:cNvSpPr txBox="1"/>
-          <p:nvPr/>
-        </p:nvSpPr>
-        <p:spPr>
-          <a:xfrm>
-            <a:off x="365760" y="182880"/>
-            <a:ext cx="11430000" cy="530352"/>
-          </a:xfrm>
-          <a:prstGeom prst="rect">
-            <a:avLst/>
-          </a:prstGeom>
-          <a:noFill/>
-        </p:spPr>
-        <p:txBody>
-          <a:bodyPr wrap="square">
-            <a:spAutoFit/>
-          </a:bodyPr>
-          <a:lstStyle/>
-          <a:p>
-            <a:pPr algn="l"/>
-            <a:r>
               <a:rPr sz="3400" b="1" i="0">
                 <a:solidFill>
                   <a:srgbClr val="1A2744"/>
@@ -3741,14 +4389,14 @@
       </p:sp>
       <p:sp>
         <p:nvSpPr>
-          <p:cNvPr id="4" name="Rectangle 3"/>
+          <p:cNvPr id="3" name="Rectangle 2"/>
           <p:cNvSpPr/>
           <p:nvPr/>
         </p:nvSpPr>
         <p:spPr>
           <a:xfrm>
-            <a:off x="783183" y="960120"/>
-            <a:ext cx="1920240" cy="3429000"/>
+            <a:off x="457200" y="1188720"/>
+            <a:ext cx="2050084" cy="1920240"/>
           </a:xfrm>
           <a:prstGeom prst="rect">
             <a:avLst/>
@@ -3777,87 +4425,41 @@
           </a:fontRef>
         </p:style>
         <p:txBody>
-          <a:bodyPr rtlCol="0" anchor="ctr" wrap="square"/>
-          <a:lstStyle/>
-          <a:p>
-            <a:pPr algn="ctr"/>
-            <a:r>
-              <a:rPr sz="2400" b="1" i="0">
+          <a:bodyPr rtlCol="0" anchor="ctr" wrap="square" tIns="365760" lIns="45720" rIns="45720"/>
+          <a:lstStyle/>
+          <a:p>
+            <a:pPr algn="ctr"/>
+            <a:r>
+              <a:rPr sz="1900" b="1">
                 <a:solidFill>
                   <a:srgbClr val="1A2744"/>
                 </a:solidFill>
                 <a:latin typeface="Calibri"/>
               </a:rPr>
-              <a:t>Structural</a:t>
-            </a:r>
-          </a:p>
-          <a:p>
-            <a:pPr algn="ctr"/>
-            <a:r>
-              <a:rPr sz="2400" b="1" i="0">
-                <a:solidFill>
-                  <a:srgbClr val="1A2744"/>
-                </a:solidFill>
-                <a:latin typeface="Calibri"/>
-              </a:rPr>
-              <a:t>Conditions</a:t>
-            </a:r>
-          </a:p>
-        </p:txBody>
-      </p:sp>
-      <p:sp>
-        <p:nvSpPr>
-          <p:cNvPr id="5" name="TextBox 4"/>
-          <p:cNvSpPr txBox="1"/>
-          <p:nvPr/>
-        </p:nvSpPr>
-        <p:spPr>
-          <a:xfrm>
-            <a:off x="2648559" y="2473451"/>
-            <a:ext cx="365760" cy="402336"/>
-          </a:xfrm>
-          <a:prstGeom prst="rect">
-            <a:avLst/>
-          </a:prstGeom>
-          <a:noFill/>
-        </p:spPr>
-        <p:txBody>
-          <a:bodyPr wrap="square">
-            <a:spAutoFit/>
-          </a:bodyPr>
-          <a:lstStyle/>
-          <a:p>
-            <a:pPr algn="ctr"/>
-            <a:r>
-              <a:rPr sz="2200" b="1" i="0">
-                <a:solidFill>
-                  <a:srgbClr val="2E7D87"/>
-                </a:solidFill>
-                <a:latin typeface="Calibri"/>
-              </a:rPr>
-              <a:t>→</a:t>
-            </a:r>
-          </a:p>
-        </p:txBody>
-      </p:sp>
-      <p:sp>
-        <p:nvSpPr>
-          <p:cNvPr id="6" name="Rectangle 5"/>
+              <a:t>Structural
+Conditions</a:t>
+            </a:r>
+          </a:p>
+        </p:txBody>
+      </p:sp>
+      <p:sp>
+        <p:nvSpPr>
+          <p:cNvPr id="4" name="Can 3"/>
           <p:cNvSpPr/>
           <p:nvPr/>
         </p:nvSpPr>
         <p:spPr>
           <a:xfrm>
-            <a:off x="2959455" y="960120"/>
-            <a:ext cx="1920240" cy="3429000"/>
-          </a:xfrm>
-          <a:prstGeom prst="rect">
+            <a:off x="2507284" y="1984248"/>
+            <a:ext cx="256032" cy="329184"/>
+          </a:xfrm>
+          <a:prstGeom prst="can">
             <a:avLst/>
           </a:prstGeom>
           <a:solidFill>
-            <a:srgbClr val="FFFFFF"/>
+            <a:srgbClr val="2E7D87"/>
           </a:solidFill>
-          <a:ln w="25400">
+          <a:ln>
             <a:solidFill>
               <a:srgbClr val="2E7D87"/>
             </a:solidFill>
@@ -3878,79 +4480,23 @@
           </a:fontRef>
         </p:style>
         <p:txBody>
-          <a:bodyPr rtlCol="0" anchor="ctr" wrap="square"/>
-          <a:lstStyle/>
-          <a:p>
-            <a:pPr algn="ctr"/>
-            <a:r>
-              <a:rPr sz="2400" b="1" i="0">
-                <a:solidFill>
-                  <a:srgbClr val="1A2744"/>
-                </a:solidFill>
-                <a:latin typeface="Calibri"/>
-              </a:rPr>
-              <a:t>Manager</a:t>
-            </a:r>
-          </a:p>
-          <a:p>
-            <a:pPr algn="ctr"/>
-            <a:r>
-              <a:rPr sz="2400" b="1" i="0">
-                <a:solidFill>
-                  <a:srgbClr val="1A2744"/>
-                </a:solidFill>
-                <a:latin typeface="Calibri"/>
-              </a:rPr>
-              <a:t>Experience</a:t>
-            </a:r>
-          </a:p>
-        </p:txBody>
-      </p:sp>
-      <p:sp>
-        <p:nvSpPr>
-          <p:cNvPr id="7" name="TextBox 6"/>
-          <p:cNvSpPr txBox="1"/>
-          <p:nvPr/>
-        </p:nvSpPr>
-        <p:spPr>
-          <a:xfrm>
-            <a:off x="4824831" y="2473451"/>
-            <a:ext cx="365760" cy="402336"/>
-          </a:xfrm>
-          <a:prstGeom prst="rect">
-            <a:avLst/>
-          </a:prstGeom>
-          <a:noFill/>
-        </p:spPr>
-        <p:txBody>
-          <a:bodyPr wrap="square">
-            <a:spAutoFit/>
-          </a:bodyPr>
-          <a:lstStyle/>
-          <a:p>
-            <a:pPr algn="ctr"/>
-            <a:r>
-              <a:rPr sz="2200" b="1" i="0">
-                <a:solidFill>
-                  <a:srgbClr val="2E7D87"/>
-                </a:solidFill>
-                <a:latin typeface="Calibri"/>
-              </a:rPr>
-              <a:t>→</a:t>
-            </a:r>
-          </a:p>
-        </p:txBody>
-      </p:sp>
-      <p:sp>
-        <p:nvSpPr>
-          <p:cNvPr id="8" name="Rectangle 7"/>
+          <a:bodyPr rtlCol="0" anchor="ctr"/>
+          <a:lstStyle/>
+          <a:p>
+            <a:pPr algn="ctr"/>
+          </a:p>
+        </p:txBody>
+      </p:sp>
+      <p:sp>
+        <p:nvSpPr>
+          <p:cNvPr id="5" name="Rectangle 4"/>
           <p:cNvSpPr/>
           <p:nvPr/>
         </p:nvSpPr>
         <p:spPr>
           <a:xfrm>
-            <a:off x="5135727" y="960120"/>
-            <a:ext cx="1920240" cy="3429000"/>
+            <a:off x="2763316" y="1188720"/>
+            <a:ext cx="2050084" cy="1920240"/>
           </a:xfrm>
           <a:prstGeom prst="rect">
             <a:avLst/>
@@ -3979,87 +4525,41 @@
           </a:fontRef>
         </p:style>
         <p:txBody>
-          <a:bodyPr rtlCol="0" anchor="ctr" wrap="square"/>
-          <a:lstStyle/>
-          <a:p>
-            <a:pPr algn="ctr"/>
-            <a:r>
-              <a:rPr sz="2400" b="1" i="0">
+          <a:bodyPr rtlCol="0" anchor="ctr" wrap="square" tIns="365760" lIns="45720" rIns="45720"/>
+          <a:lstStyle/>
+          <a:p>
+            <a:pPr algn="ctr"/>
+            <a:r>
+              <a:rPr sz="1900" b="1">
                 <a:solidFill>
                   <a:srgbClr val="1A2744"/>
                 </a:solidFill>
                 <a:latin typeface="Calibri"/>
               </a:rPr>
-              <a:t>Employee</a:t>
-            </a:r>
-          </a:p>
-          <a:p>
-            <a:pPr algn="ctr"/>
-            <a:r>
-              <a:rPr sz="2400" b="1" i="0">
-                <a:solidFill>
-                  <a:srgbClr val="1A2744"/>
-                </a:solidFill>
-                <a:latin typeface="Calibri"/>
-              </a:rPr>
-              <a:t>Experience</a:t>
-            </a:r>
-          </a:p>
-        </p:txBody>
-      </p:sp>
-      <p:sp>
-        <p:nvSpPr>
-          <p:cNvPr id="9" name="TextBox 8"/>
-          <p:cNvSpPr txBox="1"/>
-          <p:nvPr/>
-        </p:nvSpPr>
-        <p:spPr>
-          <a:xfrm>
-            <a:off x="7001103" y="2473451"/>
-            <a:ext cx="365760" cy="402336"/>
-          </a:xfrm>
-          <a:prstGeom prst="rect">
-            <a:avLst/>
-          </a:prstGeom>
-          <a:noFill/>
-        </p:spPr>
-        <p:txBody>
-          <a:bodyPr wrap="square">
-            <a:spAutoFit/>
-          </a:bodyPr>
-          <a:lstStyle/>
-          <a:p>
-            <a:pPr algn="ctr"/>
-            <a:r>
-              <a:rPr sz="2200" b="1" i="0">
-                <a:solidFill>
-                  <a:srgbClr val="2E7D87"/>
-                </a:solidFill>
-                <a:latin typeface="Calibri"/>
-              </a:rPr>
-              <a:t>→</a:t>
-            </a:r>
-          </a:p>
-        </p:txBody>
-      </p:sp>
-      <p:sp>
-        <p:nvSpPr>
-          <p:cNvPr id="10" name="Rectangle 9"/>
+              <a:t>Manager
+Experience</a:t>
+            </a:r>
+          </a:p>
+        </p:txBody>
+      </p:sp>
+      <p:sp>
+        <p:nvSpPr>
+          <p:cNvPr id="6" name="Can 5"/>
           <p:cNvSpPr/>
           <p:nvPr/>
         </p:nvSpPr>
         <p:spPr>
           <a:xfrm>
-            <a:off x="7311999" y="960120"/>
-            <a:ext cx="1920240" cy="3429000"/>
-          </a:xfrm>
-          <a:prstGeom prst="rect">
+            <a:off x="4813401" y="1984248"/>
+            <a:ext cx="256032" cy="329184"/>
+          </a:xfrm>
+          <a:prstGeom prst="can">
             <a:avLst/>
           </a:prstGeom>
           <a:solidFill>
-            <a:srgbClr val="FFFFFF"/>
+            <a:srgbClr val="2E7D87"/>
           </a:solidFill>
-          <a:ln w="25400">
+          <a:ln>
             <a:solidFill>
               <a:srgbClr val="2E7D87"/>
             </a:solidFill>
@@ -4080,79 +4580,23 @@
           </a:fontRef>
         </p:style>
         <p:txBody>
-          <a:bodyPr rtlCol="0" anchor="ctr" wrap="square"/>
-          <a:lstStyle/>
-          <a:p>
-            <a:pPr algn="ctr"/>
-            <a:r>
-              <a:rPr sz="2400" b="1" i="0">
-                <a:solidFill>
-                  <a:srgbClr val="1A2744"/>
-                </a:solidFill>
-                <a:latin typeface="Calibri"/>
-              </a:rPr>
-              <a:t>What</a:t>
-            </a:r>
-          </a:p>
-          <a:p>
-            <a:pPr algn="ctr"/>
-            <a:r>
-              <a:rPr sz="2400" b="1" i="0">
-                <a:solidFill>
-                  <a:srgbClr val="1A2744"/>
-                </a:solidFill>
-                <a:latin typeface="Calibri"/>
-              </a:rPr>
-              <a:t>You See</a:t>
-            </a:r>
-          </a:p>
-        </p:txBody>
-      </p:sp>
-      <p:sp>
-        <p:nvSpPr>
-          <p:cNvPr id="11" name="TextBox 10"/>
-          <p:cNvSpPr txBox="1"/>
-          <p:nvPr/>
-        </p:nvSpPr>
-        <p:spPr>
-          <a:xfrm>
-            <a:off x="9177375" y="2473451"/>
-            <a:ext cx="365760" cy="402336"/>
-          </a:xfrm>
-          <a:prstGeom prst="rect">
-            <a:avLst/>
-          </a:prstGeom>
-          <a:noFill/>
-        </p:spPr>
-        <p:txBody>
-          <a:bodyPr wrap="square">
-            <a:spAutoFit/>
-          </a:bodyPr>
-          <a:lstStyle/>
-          <a:p>
-            <a:pPr algn="ctr"/>
-            <a:r>
-              <a:rPr sz="2200" b="1" i="0">
-                <a:solidFill>
-                  <a:srgbClr val="2E7D87"/>
-                </a:solidFill>
-                <a:latin typeface="Calibri"/>
-              </a:rPr>
-              <a:t>→</a:t>
-            </a:r>
-          </a:p>
-        </p:txBody>
-      </p:sp>
-      <p:sp>
-        <p:nvSpPr>
-          <p:cNvPr id="12" name="Rectangle 11"/>
+          <a:bodyPr rtlCol="0" anchor="ctr"/>
+          <a:lstStyle/>
+          <a:p>
+            <a:pPr algn="ctr"/>
+          </a:p>
+        </p:txBody>
+      </p:sp>
+      <p:sp>
+        <p:nvSpPr>
+          <p:cNvPr id="7" name="Rectangle 6"/>
           <p:cNvSpPr/>
           <p:nvPr/>
         </p:nvSpPr>
         <p:spPr>
           <a:xfrm>
-            <a:off x="9488271" y="960120"/>
-            <a:ext cx="1920240" cy="3429000"/>
+            <a:off x="5069433" y="1188720"/>
+            <a:ext cx="2050084" cy="1920240"/>
           </a:xfrm>
           <a:prstGeom prst="rect">
             <a:avLst/>
@@ -4181,44 +4625,133 @@
           </a:fontRef>
         </p:style>
         <p:txBody>
-          <a:bodyPr rtlCol="0" anchor="ctr" wrap="square"/>
-          <a:lstStyle/>
-          <a:p>
-            <a:pPr algn="ctr"/>
-            <a:r>
-              <a:rPr sz="2400" b="1" i="0">
+          <a:bodyPr rtlCol="0" anchor="ctr" wrap="square" tIns="365760" lIns="45720" rIns="45720"/>
+          <a:lstStyle/>
+          <a:p>
+            <a:pPr algn="ctr"/>
+            <a:r>
+              <a:rPr sz="1900" b="1">
                 <a:solidFill>
                   <a:srgbClr val="1A2744"/>
                 </a:solidFill>
                 <a:latin typeface="Calibri"/>
               </a:rPr>
-              <a:t>What</a:t>
-            </a:r>
-          </a:p>
-          <a:p>
-            <a:pPr algn="ctr"/>
-            <a:r>
-              <a:rPr sz="2400" b="1" i="0">
+              <a:t>Employee
+Experience</a:t>
+            </a:r>
+          </a:p>
+        </p:txBody>
+      </p:sp>
+      <p:sp>
+        <p:nvSpPr>
+          <p:cNvPr id="8" name="Can 7"/>
+          <p:cNvSpPr/>
+          <p:nvPr/>
+        </p:nvSpPr>
+        <p:spPr>
+          <a:xfrm>
+            <a:off x="7119518" y="1984248"/>
+            <a:ext cx="256032" cy="329184"/>
+          </a:xfrm>
+          <a:prstGeom prst="can">
+            <a:avLst/>
+          </a:prstGeom>
+          <a:solidFill>
+            <a:srgbClr val="2E7D87"/>
+          </a:solidFill>
+          <a:ln>
+            <a:solidFill>
+              <a:srgbClr val="2E7D87"/>
+            </a:solidFill>
+          </a:ln>
+        </p:spPr>
+        <p:style>
+          <a:lnRef idx="1">
+            <a:schemeClr val="accent1"/>
+          </a:lnRef>
+          <a:fillRef idx="3">
+            <a:schemeClr val="accent1"/>
+          </a:fillRef>
+          <a:effectRef idx="2">
+            <a:schemeClr val="accent1"/>
+          </a:effectRef>
+          <a:fontRef idx="minor">
+            <a:schemeClr val="lt1"/>
+          </a:fontRef>
+        </p:style>
+        <p:txBody>
+          <a:bodyPr rtlCol="0" anchor="ctr"/>
+          <a:lstStyle/>
+          <a:p>
+            <a:pPr algn="ctr"/>
+          </a:p>
+        </p:txBody>
+      </p:sp>
+      <p:sp>
+        <p:nvSpPr>
+          <p:cNvPr id="9" name="Rectangle 8"/>
+          <p:cNvSpPr/>
+          <p:nvPr/>
+        </p:nvSpPr>
+        <p:spPr>
+          <a:xfrm>
+            <a:off x="7375550" y="1188720"/>
+            <a:ext cx="2050084" cy="1920240"/>
+          </a:xfrm>
+          <a:prstGeom prst="rect">
+            <a:avLst/>
+          </a:prstGeom>
+          <a:solidFill>
+            <a:srgbClr val="FFFFFF"/>
+          </a:solidFill>
+          <a:ln w="25400">
+            <a:solidFill>
+              <a:srgbClr val="2E7D87"/>
+            </a:solidFill>
+          </a:ln>
+        </p:spPr>
+        <p:style>
+          <a:lnRef idx="1">
+            <a:schemeClr val="accent1"/>
+          </a:lnRef>
+          <a:fillRef idx="3">
+            <a:schemeClr val="accent1"/>
+          </a:fillRef>
+          <a:effectRef idx="2">
+            <a:schemeClr val="accent1"/>
+          </a:effectRef>
+          <a:fontRef idx="minor">
+            <a:schemeClr val="lt1"/>
+          </a:fontRef>
+        </p:style>
+        <p:txBody>
+          <a:bodyPr rtlCol="0" anchor="ctr" wrap="square" tIns="365760" lIns="45720" rIns="45720"/>
+          <a:lstStyle/>
+          <a:p>
+            <a:pPr algn="ctr"/>
+            <a:r>
+              <a:rPr sz="1900" b="1">
                 <a:solidFill>
                   <a:srgbClr val="1A2744"/>
                 </a:solidFill>
                 <a:latin typeface="Calibri"/>
               </a:rPr>
-              <a:t>It Costs</a:t>
-            </a:r>
-          </a:p>
-        </p:txBody>
-      </p:sp>
-      <p:sp>
-        <p:nvSpPr>
-          <p:cNvPr id="13" name="TextBox 12"/>
+              <a:t>What
+You See</a:t>
+            </a:r>
+          </a:p>
+        </p:txBody>
+      </p:sp>
+      <p:sp>
+        <p:nvSpPr>
+          <p:cNvPr id="10" name="TextBox 9"/>
           <p:cNvSpPr txBox="1"/>
           <p:nvPr/>
         </p:nvSpPr>
         <p:spPr>
           <a:xfrm>
-            <a:off x="7311999" y="4480559"/>
-            <a:ext cx="1920240" cy="594360"/>
+            <a:off x="7375550" y="3200400"/>
+            <a:ext cx="2050084" cy="594360"/>
           </a:xfrm>
           <a:prstGeom prst="rect">
             <a:avLst/>
@@ -4233,39 +4766,128 @@
           <a:p>
             <a:pPr algn="ctr"/>
             <a:r>
-              <a:rPr sz="1600" b="0" i="0">
+              <a:rPr sz="1500" b="0" i="1">
                 <a:solidFill>
                   <a:srgbClr val="1A2744"/>
                 </a:solidFill>
                 <a:latin typeface="Calibri"/>
               </a:rPr>
-              <a:t>conflict · avoidance</a:t>
-            </a:r>
-          </a:p>
-          <a:p>
-            <a:pPr algn="ctr"/>
-            <a:r>
-              <a:rPr sz="1600" b="0" i="0">
+              <a:t>conflict · avoidance
+turnover · inconsistency</a:t>
+            </a:r>
+          </a:p>
+        </p:txBody>
+      </p:sp>
+      <p:sp>
+        <p:nvSpPr>
+          <p:cNvPr id="11" name="Can 10"/>
+          <p:cNvSpPr/>
+          <p:nvPr/>
+        </p:nvSpPr>
+        <p:spPr>
+          <a:xfrm>
+            <a:off x="9425635" y="1984248"/>
+            <a:ext cx="256032" cy="329184"/>
+          </a:xfrm>
+          <a:prstGeom prst="can">
+            <a:avLst/>
+          </a:prstGeom>
+          <a:solidFill>
+            <a:srgbClr val="2E7D87"/>
+          </a:solidFill>
+          <a:ln>
+            <a:solidFill>
+              <a:srgbClr val="2E7D87"/>
+            </a:solidFill>
+          </a:ln>
+        </p:spPr>
+        <p:style>
+          <a:lnRef idx="1">
+            <a:schemeClr val="accent1"/>
+          </a:lnRef>
+          <a:fillRef idx="3">
+            <a:schemeClr val="accent1"/>
+          </a:fillRef>
+          <a:effectRef idx="2">
+            <a:schemeClr val="accent1"/>
+          </a:effectRef>
+          <a:fontRef idx="minor">
+            <a:schemeClr val="lt1"/>
+          </a:fontRef>
+        </p:style>
+        <p:txBody>
+          <a:bodyPr rtlCol="0" anchor="ctr"/>
+          <a:lstStyle/>
+          <a:p>
+            <a:pPr algn="ctr"/>
+          </a:p>
+        </p:txBody>
+      </p:sp>
+      <p:sp>
+        <p:nvSpPr>
+          <p:cNvPr id="12" name="Rectangle 11"/>
+          <p:cNvSpPr/>
+          <p:nvPr/>
+        </p:nvSpPr>
+        <p:spPr>
+          <a:xfrm>
+            <a:off x="9681667" y="1188720"/>
+            <a:ext cx="2050084" cy="1920240"/>
+          </a:xfrm>
+          <a:prstGeom prst="rect">
+            <a:avLst/>
+          </a:prstGeom>
+          <a:solidFill>
+            <a:srgbClr val="FFFFFF"/>
+          </a:solidFill>
+          <a:ln w="25400">
+            <a:solidFill>
+              <a:srgbClr val="2E7D87"/>
+            </a:solidFill>
+          </a:ln>
+        </p:spPr>
+        <p:style>
+          <a:lnRef idx="1">
+            <a:schemeClr val="accent1"/>
+          </a:lnRef>
+          <a:fillRef idx="3">
+            <a:schemeClr val="accent1"/>
+          </a:fillRef>
+          <a:effectRef idx="2">
+            <a:schemeClr val="accent1"/>
+          </a:effectRef>
+          <a:fontRef idx="minor">
+            <a:schemeClr val="lt1"/>
+          </a:fontRef>
+        </p:style>
+        <p:txBody>
+          <a:bodyPr rtlCol="0" anchor="ctr" wrap="square" tIns="365760" lIns="45720" rIns="45720"/>
+          <a:lstStyle/>
+          <a:p>
+            <a:pPr algn="ctr"/>
+            <a:r>
+              <a:rPr sz="1900" b="1">
                 <a:solidFill>
                   <a:srgbClr val="1A2744"/>
                 </a:solidFill>
                 <a:latin typeface="Calibri"/>
               </a:rPr>
-              <a:t>turnover · inconsistency</a:t>
-            </a:r>
-          </a:p>
-        </p:txBody>
-      </p:sp>
-      <p:sp>
-        <p:nvSpPr>
-          <p:cNvPr id="14" name="TextBox 13"/>
+              <a:t>What
+It Costs</a:t>
+            </a:r>
+          </a:p>
+        </p:txBody>
+      </p:sp>
+      <p:sp>
+        <p:nvSpPr>
+          <p:cNvPr id="13" name="TextBox 12"/>
           <p:cNvSpPr txBox="1"/>
           <p:nvPr/>
         </p:nvSpPr>
         <p:spPr>
           <a:xfrm>
-            <a:off x="9488271" y="4480559"/>
-            <a:ext cx="1920240" cy="594360"/>
+            <a:off x="9681667" y="3200400"/>
+            <a:ext cx="2050084" cy="594360"/>
           </a:xfrm>
           <a:prstGeom prst="rect">
             <a:avLst/>
@@ -4280,7 +4902,7 @@
           <a:p>
             <a:pPr algn="ctr"/>
             <a:r>
-              <a:rPr sz="1600" b="0" i="0">
+              <a:rPr sz="1500" b="0" i="1">
                 <a:solidFill>
                   <a:srgbClr val="1A2744"/>
                 </a:solidFill>
@@ -4293,14 +4915,14 @@
       </p:sp>
       <p:sp>
         <p:nvSpPr>
-          <p:cNvPr id="15" name="TextBox 14"/>
+          <p:cNvPr id="14" name="TextBox 13"/>
           <p:cNvSpPr txBox="1"/>
           <p:nvPr/>
         </p:nvSpPr>
         <p:spPr>
           <a:xfrm>
-            <a:off x="365760" y="6263640"/>
-            <a:ext cx="11430000" cy="438912"/>
+            <a:off x="457200" y="6080760"/>
+            <a:ext cx="11274552" cy="548640"/>
           </a:xfrm>
           <a:prstGeom prst="rect">
             <a:avLst/>
@@ -4360,8 +4982,8 @@
         </p:nvSpPr>
         <p:spPr>
           <a:xfrm>
-            <a:off x="201168" y="91440"/>
-            <a:ext cx="502920" cy="274320"/>
+            <a:off x="457200" y="594360"/>
+            <a:ext cx="11274552" cy="594360"/>
           </a:xfrm>
           <a:prstGeom prst="rect">
             <a:avLst/>
@@ -4374,15 +4996,15 @@
           </a:bodyPr>
           <a:lstStyle/>
           <a:p>
-            <a:pPr algn="l"/>
-            <a:r>
-              <a:rPr sz="1300" b="1" i="0">
-                <a:solidFill>
-                  <a:srgbClr val="2E7D87"/>
+            <a:pPr algn="ctr"/>
+            <a:r>
+              <a:rPr sz="2600" b="0" i="0">
+                <a:solidFill>
+                  <a:srgbClr val="1A2744"/>
                 </a:solidFill>
                 <a:latin typeface="Calibri"/>
               </a:rPr>
-              <a:t>03</a:t>
+              <a:t>400 employees   ×   ~75% annual turnover   =   ~300 replacements / year</a:t>
             </a:r>
           </a:p>
         </p:txBody>
@@ -4395,8 +5017,8 @@
         </p:nvSpPr>
         <p:spPr>
           <a:xfrm>
-            <a:off x="457200" y="411480"/>
-            <a:ext cx="11247120" cy="594360"/>
+            <a:off x="457200" y="1417320"/>
+            <a:ext cx="11274552" cy="1280160"/>
           </a:xfrm>
           <a:prstGeom prst="rect">
             <a:avLst/>
@@ -4411,13 +5033,13 @@
           <a:p>
             <a:pPr algn="ctr"/>
             <a:r>
-              <a:rPr sz="2600" b="0" i="0">
-                <a:solidFill>
-                  <a:srgbClr val="1A2744"/>
+              <a:rPr sz="6400" b="1" i="0">
+                <a:solidFill>
+                  <a:srgbClr val="2E7D87"/>
                 </a:solidFill>
                 <a:latin typeface="Calibri"/>
               </a:rPr>
-              <a:t>400 employees   ×   ~75% annual turnover   =   ~300 replacements / year</a:t>
+              <a:t>$1,200,000</a:t>
             </a:r>
           </a:p>
         </p:txBody>
@@ -4430,8 +5052,8 @@
         </p:nvSpPr>
         <p:spPr>
           <a:xfrm>
-            <a:off x="548640" y="1188720"/>
-            <a:ext cx="11064240" cy="1463040"/>
+            <a:off x="457200" y="2788920"/>
+            <a:ext cx="11274552" cy="594360"/>
           </a:xfrm>
           <a:prstGeom prst="rect">
             <a:avLst/>
@@ -4446,42 +5068,7 @@
           <a:p>
             <a:pPr algn="ctr"/>
             <a:r>
-              <a:rPr sz="7600" b="1" i="0">
-                <a:solidFill>
-                  <a:srgbClr val="2E7D87"/>
-                </a:solidFill>
-                <a:latin typeface="Calibri"/>
-              </a:rPr>
-              <a:t>$1,200,000</a:t>
-            </a:r>
-          </a:p>
-        </p:txBody>
-      </p:sp>
-      <p:sp>
-        <p:nvSpPr>
-          <p:cNvPr id="5" name="TextBox 4"/>
-          <p:cNvSpPr txBox="1"/>
-          <p:nvPr/>
-        </p:nvSpPr>
-        <p:spPr>
-          <a:xfrm>
-            <a:off x="548640" y="2743200"/>
-            <a:ext cx="11064240" cy="502920"/>
-          </a:xfrm>
-          <a:prstGeom prst="rect">
-            <a:avLst/>
-          </a:prstGeom>
-          <a:noFill/>
-        </p:spPr>
-        <p:txBody>
-          <a:bodyPr wrap="square">
-            <a:spAutoFit/>
-          </a:bodyPr>
-          <a:lstStyle/>
-          <a:p>
-            <a:pPr algn="ctr"/>
-            <a:r>
-              <a:rPr sz="2200" b="0" i="0">
+              <a:rPr sz="2000" b="0" i="0">
                 <a:solidFill>
                   <a:srgbClr val="1A2744"/>
                 </a:solidFill>
@@ -4494,20 +5081,20 @@
       </p:sp>
       <p:sp>
         <p:nvSpPr>
-          <p:cNvPr id="6" name="Rectangle 5"/>
+          <p:cNvPr id="5" name="Rectangle 4"/>
           <p:cNvSpPr/>
           <p:nvPr/>
         </p:nvSpPr>
         <p:spPr>
           <a:xfrm>
-            <a:off x="1280160" y="3429000"/>
-            <a:ext cx="9601200" cy="36576"/>
+            <a:off x="457200" y="3611880"/>
+            <a:ext cx="11274552" cy="22860"/>
           </a:xfrm>
           <a:prstGeom prst="rect">
             <a:avLst/>
           </a:prstGeom>
           <a:solidFill>
-            <a:srgbClr val="2E7D87"/>
+            <a:srgbClr val="CCCCCC"/>
           </a:solidFill>
           <a:ln>
             <a:noFill/>
@@ -4537,14 +5124,14 @@
       </p:sp>
       <p:sp>
         <p:nvSpPr>
-          <p:cNvPr id="7" name="TextBox 6"/>
+          <p:cNvPr id="6" name="TextBox 5"/>
           <p:cNvSpPr txBox="1"/>
           <p:nvPr/>
         </p:nvSpPr>
         <p:spPr>
           <a:xfrm>
-            <a:off x="548640" y="3611880"/>
-            <a:ext cx="11064240" cy="502920"/>
+            <a:off x="457200" y="3794760"/>
+            <a:ext cx="11274552" cy="548640"/>
           </a:xfrm>
           <a:prstGeom prst="rect">
             <a:avLst/>
@@ -4559,7 +5146,7 @@
           <a:p>
             <a:pPr algn="ctr"/>
             <a:r>
-              <a:rPr sz="2600" b="1" i="0">
+              <a:rPr sz="2800" b="1" i="0">
                 <a:solidFill>
                   <a:srgbClr val="1A2744"/>
                 </a:solidFill>
@@ -4572,14 +5159,14 @@
       </p:sp>
       <p:sp>
         <p:nvSpPr>
-          <p:cNvPr id="8" name="TextBox 7"/>
+          <p:cNvPr id="7" name="TextBox 6"/>
           <p:cNvSpPr txBox="1"/>
           <p:nvPr/>
         </p:nvSpPr>
         <p:spPr>
           <a:xfrm>
-            <a:off x="548640" y="4251960"/>
-            <a:ext cx="11064240" cy="502920"/>
+            <a:off x="457200" y="4434840"/>
+            <a:ext cx="11274552" cy="548640"/>
           </a:xfrm>
           <a:prstGeom prst="rect">
             <a:avLst/>
@@ -4594,7 +5181,7 @@
           <a:p>
             <a:pPr algn="ctr"/>
             <a:r>
-              <a:rPr sz="2200" b="0" i="1">
+              <a:rPr sz="2200" b="0" i="0">
                 <a:solidFill>
                   <a:srgbClr val="1A2744"/>
                 </a:solidFill>
@@ -4639,8 +5226,8 @@
         </p:nvSpPr>
         <p:spPr>
           <a:xfrm>
-            <a:off x="201168" y="91440"/>
-            <a:ext cx="502920" cy="274320"/>
+            <a:off x="457200" y="365760"/>
+            <a:ext cx="11274552" cy="594360"/>
           </a:xfrm>
           <a:prstGeom prst="rect">
             <a:avLst/>
@@ -4655,41 +5242,6 @@
           <a:p>
             <a:pPr algn="l"/>
             <a:r>
-              <a:rPr sz="1300" b="1" i="0">
-                <a:solidFill>
-                  <a:srgbClr val="2E7D87"/>
-                </a:solidFill>
-                <a:latin typeface="Calibri"/>
-              </a:rPr>
-              <a:t>04</a:t>
-            </a:r>
-          </a:p>
-        </p:txBody>
-      </p:sp>
-      <p:sp>
-        <p:nvSpPr>
-          <p:cNvPr id="3" name="TextBox 2"/>
-          <p:cNvSpPr txBox="1"/>
-          <p:nvPr/>
-        </p:nvSpPr>
-        <p:spPr>
-          <a:xfrm>
-            <a:off x="365760" y="182880"/>
-            <a:ext cx="11430000" cy="548640"/>
-          </a:xfrm>
-          <a:prstGeom prst="rect">
-            <a:avLst/>
-          </a:prstGeom>
-          <a:noFill/>
-        </p:spPr>
-        <p:txBody>
-          <a:bodyPr wrap="square">
-            <a:spAutoFit/>
-          </a:bodyPr>
-          <a:lstStyle/>
-          <a:p>
-            <a:pPr algn="l"/>
-            <a:r>
               <a:rPr sz="3400" b="1" i="0">
                 <a:solidFill>
                   <a:srgbClr val="1A2744"/>
@@ -4703,14 +5255,14 @@
       </p:sp>
       <p:sp>
         <p:nvSpPr>
-          <p:cNvPr id="4" name="Rectangle 3"/>
+          <p:cNvPr id="3" name="Rectangle 2"/>
           <p:cNvSpPr/>
           <p:nvPr/>
         </p:nvSpPr>
         <p:spPr>
           <a:xfrm>
-            <a:off x="527151" y="960120"/>
-            <a:ext cx="3566160" cy="4572000"/>
+            <a:off x="457200" y="1188720"/>
+            <a:ext cx="3636264" cy="4389120"/>
           </a:xfrm>
           <a:prstGeom prst="rect">
             <a:avLst/>
@@ -4718,7 +5270,7 @@
           <a:solidFill>
             <a:srgbClr val="FFFFFF"/>
           </a:solidFill>
-          <a:ln w="25400">
+          <a:ln w="19050">
             <a:solidFill>
               <a:srgbClr val="2E7D87"/>
             </a:solidFill>
@@ -4739,14 +5291,14 @@
           </a:fontRef>
         </p:style>
         <p:txBody>
-          <a:bodyPr rtlCol="0" anchor="ctr" wrap="square"/>
-          <a:lstStyle/>
-          <a:p>
-            <a:pPr algn="ctr"/>
-            <a:r>
-              <a:rPr sz="2200" b="1" i="0">
-                <a:solidFill>
-                  <a:srgbClr val="1A2744"/>
+          <a:bodyPr rtlCol="0" anchor="ctr" wrap="square" lIns="73152" rIns="73152" tIns="109728"/>
+          <a:lstStyle/>
+          <a:p>
+            <a:pPr algn="ctr"/>
+            <a:r>
+              <a:rPr sz="2000" b="1">
+                <a:solidFill>
+                  <a:srgbClr val="2E7D87"/>
                 </a:solidFill>
                 <a:latin typeface="Calibri"/>
               </a:rPr>
@@ -4756,19 +5308,7 @@
           <a:p>
             <a:pPr algn="ctr"/>
             <a:r>
-              <a:rPr sz="600" b="0" i="0">
-                <a:solidFill>
-                  <a:srgbClr val="1A2744"/>
-                </a:solidFill>
-                <a:latin typeface="Calibri"/>
-              </a:rPr>
-              <a:t/>
-            </a:r>
-          </a:p>
-          <a:p>
-            <a:pPr algn="ctr"/>
-            <a:r>
-              <a:rPr sz="1900" b="0" i="0">
+              <a:rPr sz="1800">
                 <a:solidFill>
                   <a:srgbClr val="1A2744"/>
                 </a:solidFill>
@@ -4780,43 +5320,31 @@
           <a:p>
             <a:pPr algn="ctr"/>
             <a:r>
-              <a:rPr sz="600" b="0" i="0">
+              <a:rPr sz="1800">
                 <a:solidFill>
                   <a:srgbClr val="1A2744"/>
                 </a:solidFill>
                 <a:latin typeface="Calibri"/>
               </a:rPr>
-              <a:t/>
-            </a:r>
-          </a:p>
-          <a:p>
-            <a:pPr algn="ctr"/>
-            <a:r>
-              <a:rPr sz="1900" b="0" i="0">
+              <a:t>What their patterns are</a:t>
+            </a:r>
+          </a:p>
+          <a:p>
+            <a:pPr algn="ctr"/>
+            <a:r>
+              <a:rPr sz="1800">
                 <a:solidFill>
                   <a:srgbClr val="1A2744"/>
                 </a:solidFill>
                 <a:latin typeface="Calibri"/>
               </a:rPr>
-              <a:t>What their patterns are ·</a:t>
-            </a:r>
-          </a:p>
-          <a:p>
-            <a:pPr algn="ctr"/>
-            <a:r>
-              <a:rPr sz="1900" b="0" i="0">
-                <a:solidFill>
-                  <a:srgbClr val="1A2744"/>
-                </a:solidFill>
-                <a:latin typeface="Calibri"/>
-              </a:rPr>
-              <a:t>What activates them ·</a:t>
-            </a:r>
-          </a:p>
-          <a:p>
-            <a:pPr algn="ctr"/>
-            <a:r>
-              <a:rPr sz="1900" b="0" i="0">
+              <a:t>What activates them</a:t>
+            </a:r>
+          </a:p>
+          <a:p>
+            <a:pPr algn="ctr"/>
+            <a:r>
+              <a:rPr sz="1800">
                 <a:solidFill>
                   <a:srgbClr val="1A2744"/>
                 </a:solidFill>
@@ -4829,14 +5357,14 @@
       </p:sp>
       <p:sp>
         <p:nvSpPr>
-          <p:cNvPr id="5" name="Rectangle 4"/>
+          <p:cNvPr id="4" name="Rectangle 3"/>
           <p:cNvSpPr/>
           <p:nvPr/>
         </p:nvSpPr>
         <p:spPr>
           <a:xfrm>
-            <a:off x="4312767" y="960120"/>
-            <a:ext cx="3566160" cy="4572000"/>
+            <a:off x="4276344" y="1188720"/>
+            <a:ext cx="3636264" cy="4389120"/>
           </a:xfrm>
           <a:prstGeom prst="rect">
             <a:avLst/>
@@ -4844,7 +5372,7 @@
           <a:solidFill>
             <a:srgbClr val="FFFFFF"/>
           </a:solidFill>
-          <a:ln w="25400">
+          <a:ln w="19050">
             <a:solidFill>
               <a:srgbClr val="2E7D87"/>
             </a:solidFill>
@@ -4865,14 +5393,14 @@
           </a:fontRef>
         </p:style>
         <p:txBody>
-          <a:bodyPr rtlCol="0" anchor="ctr" wrap="square"/>
-          <a:lstStyle/>
-          <a:p>
-            <a:pPr algn="ctr"/>
-            <a:r>
-              <a:rPr sz="2200" b="1" i="0">
-                <a:solidFill>
-                  <a:srgbClr val="1A2744"/>
+          <a:bodyPr rtlCol="0" anchor="ctr" wrap="square" lIns="73152" rIns="73152" tIns="109728"/>
+          <a:lstStyle/>
+          <a:p>
+            <a:pPr algn="ctr"/>
+            <a:r>
+              <a:rPr sz="2000" b="1">
+                <a:solidFill>
+                  <a:srgbClr val="2E7D87"/>
                 </a:solidFill>
                 <a:latin typeface="Calibri"/>
               </a:rPr>
@@ -4882,19 +5410,7 @@
           <a:p>
             <a:pPr algn="ctr"/>
             <a:r>
-              <a:rPr sz="600" b="0" i="0">
-                <a:solidFill>
-                  <a:srgbClr val="1A2744"/>
-                </a:solidFill>
-                <a:latin typeface="Calibri"/>
-              </a:rPr>
-              <a:t/>
-            </a:r>
-          </a:p>
-          <a:p>
-            <a:pPr algn="ctr"/>
-            <a:r>
-              <a:rPr sz="1900" b="0" i="0">
+              <a:rPr sz="1800">
                 <a:solidFill>
                   <a:srgbClr val="1A2744"/>
                 </a:solidFill>
@@ -4906,7 +5422,7 @@
           <a:p>
             <a:pPr algn="ctr"/>
             <a:r>
-              <a:rPr sz="1900" b="0" i="0">
+              <a:rPr sz="1800">
                 <a:solidFill>
                   <a:srgbClr val="1A2744"/>
                 </a:solidFill>
@@ -4918,19 +5434,7 @@
           <a:p>
             <a:pPr algn="ctr"/>
             <a:r>
-              <a:rPr sz="600" b="0" i="0">
-                <a:solidFill>
-                  <a:srgbClr val="1A2744"/>
-                </a:solidFill>
-                <a:latin typeface="Calibri"/>
-              </a:rPr>
-              <a:t/>
-            </a:r>
-          </a:p>
-          <a:p>
-            <a:pPr algn="ctr"/>
-            <a:r>
-              <a:rPr sz="1900" b="0" i="0">
+              <a:rPr sz="1800">
                 <a:solidFill>
                   <a:srgbClr val="1A2744"/>
                 </a:solidFill>
@@ -4942,7 +5446,7 @@
           <a:p>
             <a:pPr algn="ctr"/>
             <a:r>
-              <a:rPr sz="1900" b="0" i="0">
+              <a:rPr sz="1800">
                 <a:solidFill>
                   <a:srgbClr val="1A2744"/>
                 </a:solidFill>
@@ -4955,14 +5459,14 @@
       </p:sp>
       <p:sp>
         <p:nvSpPr>
-          <p:cNvPr id="6" name="Rectangle 5"/>
+          <p:cNvPr id="5" name="Rectangle 4"/>
           <p:cNvSpPr/>
           <p:nvPr/>
         </p:nvSpPr>
         <p:spPr>
           <a:xfrm>
-            <a:off x="8098383" y="960120"/>
-            <a:ext cx="3566160" cy="4572000"/>
+            <a:off x="8095488" y="1188720"/>
+            <a:ext cx="3636264" cy="4389120"/>
           </a:xfrm>
           <a:prstGeom prst="rect">
             <a:avLst/>
@@ -4970,7 +5474,7 @@
           <a:solidFill>
             <a:srgbClr val="FFFFFF"/>
           </a:solidFill>
-          <a:ln w="25400">
+          <a:ln w="19050">
             <a:solidFill>
               <a:srgbClr val="2E7D87"/>
             </a:solidFill>
@@ -4991,48 +5495,25 @@
           </a:fontRef>
         </p:style>
         <p:txBody>
-          <a:bodyPr rtlCol="0" anchor="ctr" wrap="square"/>
-          <a:lstStyle/>
-          <a:p>
-            <a:pPr algn="ctr"/>
-            <a:r>
-              <a:rPr sz="2200" b="1" i="0">
-                <a:solidFill>
-                  <a:srgbClr val="1A2744"/>
+          <a:bodyPr rtlCol="0" anchor="ctr" wrap="square" lIns="73152" rIns="73152" tIns="109728"/>
+          <a:lstStyle/>
+          <a:p>
+            <a:pPr algn="ctr"/>
+            <a:r>
+              <a:rPr sz="2000" b="1">
+                <a:solidFill>
+                  <a:srgbClr val="2E7D87"/>
                 </a:solidFill>
                 <a:latin typeface="Calibri"/>
               </a:rPr>
-              <a:t>STRUCTURAL</a:t>
-            </a:r>
-          </a:p>
-          <a:p>
-            <a:pPr algn="ctr"/>
-            <a:r>
-              <a:rPr sz="2200" b="1" i="0">
-                <a:solidFill>
-                  <a:srgbClr val="1A2744"/>
-                </a:solidFill>
-                <a:latin typeface="Calibri"/>
-              </a:rPr>
-              <a:t>RECOMMENDATIONS</a:t>
-            </a:r>
-          </a:p>
-          <a:p>
-            <a:pPr algn="ctr"/>
-            <a:r>
-              <a:rPr sz="600" b="0" i="0">
-                <a:solidFill>
-                  <a:srgbClr val="1A2744"/>
-                </a:solidFill>
-                <a:latin typeface="Calibri"/>
-              </a:rPr>
-              <a:t/>
-            </a:r>
-          </a:p>
-          <a:p>
-            <a:pPr algn="ctr"/>
-            <a:r>
-              <a:rPr sz="1900" b="0" i="0">
+              <a:t>STRUCTURAL
+RECOMMENDATIONS</a:t>
+            </a:r>
+          </a:p>
+          <a:p>
+            <a:pPr algn="ctr"/>
+            <a:r>
+              <a:rPr sz="1800">
                 <a:solidFill>
                   <a:srgbClr val="1A2744"/>
                 </a:solidFill>
@@ -5044,7 +5525,7 @@
           <a:p>
             <a:pPr algn="ctr"/>
             <a:r>
-              <a:rPr sz="1900" b="0" i="0">
+              <a:rPr sz="1800">
                 <a:solidFill>
                   <a:srgbClr val="1A2744"/>
                 </a:solidFill>
@@ -5056,19 +5537,7 @@
           <a:p>
             <a:pPr algn="ctr"/>
             <a:r>
-              <a:rPr sz="600" b="0" i="0">
-                <a:solidFill>
-                  <a:srgbClr val="1A2744"/>
-                </a:solidFill>
-                <a:latin typeface="Calibri"/>
-              </a:rPr>
-              <a:t/>
-            </a:r>
-          </a:p>
-          <a:p>
-            <a:pPr algn="ctr"/>
-            <a:r>
-              <a:rPr sz="1900" b="0" i="0">
+              <a:rPr sz="1800">
                 <a:solidFill>
                   <a:srgbClr val="1A2744"/>
                 </a:solidFill>
@@ -5080,7 +5549,7 @@
           <a:p>
             <a:pPr algn="ctr"/>
             <a:r>
-              <a:rPr sz="1900" b="0" i="0">
+              <a:rPr sz="1800">
                 <a:solidFill>
                   <a:srgbClr val="1A2744"/>
                 </a:solidFill>
@@ -5093,14 +5562,14 @@
       </p:sp>
       <p:sp>
         <p:nvSpPr>
-          <p:cNvPr id="7" name="TextBox 6"/>
+          <p:cNvPr id="6" name="TextBox 5"/>
           <p:cNvSpPr txBox="1"/>
           <p:nvPr/>
         </p:nvSpPr>
         <p:spPr>
           <a:xfrm>
-            <a:off x="365760" y="6263640"/>
-            <a:ext cx="11430000" cy="438912"/>
+            <a:off x="457200" y="6080760"/>
+            <a:ext cx="11274552" cy="548640"/>
           </a:xfrm>
           <a:prstGeom prst="rect">
             <a:avLst/>
@@ -5160,8 +5629,8 @@
         </p:nvSpPr>
         <p:spPr>
           <a:xfrm>
-            <a:off x="201168" y="91440"/>
-            <a:ext cx="502920" cy="274320"/>
+            <a:off x="457200" y="365760"/>
+            <a:ext cx="11274552" cy="594360"/>
           </a:xfrm>
           <a:prstGeom prst="rect">
             <a:avLst/>
@@ -5176,41 +5645,6 @@
           <a:p>
             <a:pPr algn="l"/>
             <a:r>
-              <a:rPr sz="1300" b="1" i="0">
-                <a:solidFill>
-                  <a:srgbClr val="2E7D87"/>
-                </a:solidFill>
-                <a:latin typeface="Calibri"/>
-              </a:rPr>
-              <a:t>05</a:t>
-            </a:r>
-          </a:p>
-        </p:txBody>
-      </p:sp>
-      <p:sp>
-        <p:nvSpPr>
-          <p:cNvPr id="3" name="TextBox 2"/>
-          <p:cNvSpPr txBox="1"/>
-          <p:nvPr/>
-        </p:nvSpPr>
-        <p:spPr>
-          <a:xfrm>
-            <a:off x="365760" y="182880"/>
-            <a:ext cx="11430000" cy="530352"/>
-          </a:xfrm>
-          <a:prstGeom prst="rect">
-            <a:avLst/>
-          </a:prstGeom>
-          <a:noFill/>
-        </p:spPr>
-        <p:txBody>
-          <a:bodyPr wrap="square">
-            <a:spAutoFit/>
-          </a:bodyPr>
-          <a:lstStyle/>
-          <a:p>
-            <a:pPr algn="l"/>
-            <a:r>
               <a:rPr sz="3400" b="1" i="0">
                 <a:solidFill>
                   <a:srgbClr val="1A2744"/>
@@ -5224,14 +5658,14 @@
       </p:sp>
       <p:sp>
         <p:nvSpPr>
-          <p:cNvPr id="4" name="Rectangle 3"/>
+          <p:cNvPr id="3" name="Rectangle 2"/>
           <p:cNvSpPr/>
           <p:nvPr/>
         </p:nvSpPr>
         <p:spPr>
           <a:xfrm>
-            <a:off x="685800" y="3291840"/>
-            <a:ext cx="10835640" cy="128016"/>
+            <a:off x="1828800" y="3474720"/>
+            <a:ext cx="8531352" cy="164592"/>
           </a:xfrm>
           <a:prstGeom prst="rect">
             <a:avLst/>
@@ -5267,14 +5701,14 @@
       </p:sp>
       <p:sp>
         <p:nvSpPr>
-          <p:cNvPr id="5" name="Rectangle 4"/>
+          <p:cNvPr id="4" name="Rectangle 3"/>
           <p:cNvSpPr/>
           <p:nvPr/>
         </p:nvSpPr>
         <p:spPr>
           <a:xfrm>
-            <a:off x="832103" y="3227832"/>
-            <a:ext cx="73152" cy="256032"/>
+            <a:off x="1796796" y="3273552"/>
+            <a:ext cx="64008" cy="566928"/>
           </a:xfrm>
           <a:prstGeom prst="rect">
             <a:avLst/>
@@ -5310,14 +5744,14 @@
       </p:sp>
       <p:sp>
         <p:nvSpPr>
-          <p:cNvPr id="6" name="TextBox 5"/>
+          <p:cNvPr id="5" name="TextBox 4"/>
           <p:cNvSpPr txBox="1"/>
           <p:nvPr/>
         </p:nvSpPr>
         <p:spPr>
           <a:xfrm>
-            <a:off x="-320040" y="1097280"/>
-            <a:ext cx="2377440" cy="292608"/>
+            <a:off x="685800" y="1051560"/>
+            <a:ext cx="2286000" cy="365760"/>
           </a:xfrm>
           <a:prstGeom prst="rect">
             <a:avLst/>
@@ -5332,7 +5766,7 @@
           <a:p>
             <a:pPr algn="ctr"/>
             <a:r>
-              <a:rPr sz="1500" b="0" i="0">
+              <a:rPr sz="1800" b="1" i="0">
                 <a:solidFill>
                   <a:srgbClr val="2E7D87"/>
                 </a:solidFill>
@@ -5345,14 +5779,14 @@
       </p:sp>
       <p:sp>
         <p:nvSpPr>
-          <p:cNvPr id="7" name="TextBox 6"/>
+          <p:cNvPr id="6" name="TextBox 5"/>
           <p:cNvSpPr txBox="1"/>
           <p:nvPr/>
         </p:nvSpPr>
         <p:spPr>
           <a:xfrm>
-            <a:off x="-320040" y="1371600"/>
-            <a:ext cx="2377440" cy="594360"/>
+            <a:off x="685800" y="1554480"/>
+            <a:ext cx="2286000" cy="384048"/>
           </a:xfrm>
           <a:prstGeom prst="rect">
             <a:avLst/>
@@ -5367,39 +5801,27 @@
           <a:p>
             <a:pPr algn="ctr"/>
             <a:r>
-              <a:rPr sz="1800" b="1" i="0">
+              <a:rPr sz="1500" b="1" i="0">
                 <a:solidFill>
                   <a:srgbClr val="1A2744"/>
                 </a:solidFill>
                 <a:latin typeface="Calibri"/>
               </a:rPr>
-              <a:t>PHASE 1</a:t>
-            </a:r>
-          </a:p>
-          <a:p>
-            <a:pPr algn="ctr"/>
-            <a:r>
-              <a:rPr sz="1800" b="1" i="0">
-                <a:solidFill>
-                  <a:srgbClr val="1A2744"/>
-                </a:solidFill>
-                <a:latin typeface="Calibri"/>
-              </a:rPr>
-              <a:t>COMPLETE</a:t>
-            </a:r>
-          </a:p>
-        </p:txBody>
-      </p:sp>
-      <p:sp>
-        <p:nvSpPr>
-          <p:cNvPr id="8" name="TextBox 7"/>
+              <a:t>PHASE 1 COMPLETE</a:t>
+            </a:r>
+          </a:p>
+        </p:txBody>
+      </p:sp>
+      <p:sp>
+        <p:nvSpPr>
+          <p:cNvPr id="7" name="TextBox 6"/>
           <p:cNvSpPr txBox="1"/>
           <p:nvPr/>
         </p:nvSpPr>
         <p:spPr>
           <a:xfrm>
-            <a:off x="-320040" y="1901952"/>
-            <a:ext cx="2377440" cy="1371600"/>
+            <a:off x="685800" y="2011680"/>
+            <a:ext cx="2286000" cy="777240"/>
           </a:xfrm>
           <a:prstGeom prst="rect">
             <a:avLst/>
@@ -5414,51 +5836,28 @@
           <a:p>
             <a:pPr algn="ctr"/>
             <a:r>
-              <a:rPr sz="1500" b="0" i="0">
+              <a:rPr sz="1400" b="0" i="0">
                 <a:solidFill>
                   <a:srgbClr val="1A2744"/>
                 </a:solidFill>
                 <a:latin typeface="Calibri"/>
               </a:rPr>
-              <a:t>Assessment findings +</a:t>
-            </a:r>
-          </a:p>
-          <a:p>
-            <a:pPr algn="ctr"/>
-            <a:r>
-              <a:rPr sz="1500" b="0" i="0">
-                <a:solidFill>
-                  <a:srgbClr val="1A2744"/>
-                </a:solidFill>
-                <a:latin typeface="Calibri"/>
-              </a:rPr>
-              <a:t>structural recommendations</a:t>
-            </a:r>
-          </a:p>
-          <a:p>
-            <a:pPr algn="ctr"/>
-            <a:r>
-              <a:rPr sz="1500" b="0" i="0">
-                <a:solidFill>
-                  <a:srgbClr val="1A2744"/>
-                </a:solidFill>
-                <a:latin typeface="Calibri"/>
-              </a:rPr>
-              <a:t>delivered</a:t>
-            </a:r>
-          </a:p>
-        </p:txBody>
-      </p:sp>
-      <p:sp>
-        <p:nvSpPr>
-          <p:cNvPr id="9" name="Rectangle 8"/>
+              <a:t>Assessment findings +
+structural recommendations delivered</a:t>
+            </a:r>
+          </a:p>
+        </p:txBody>
+      </p:sp>
+      <p:sp>
+        <p:nvSpPr>
+          <p:cNvPr id="8" name="Rectangle 7"/>
           <p:cNvSpPr/>
           <p:nvPr/>
         </p:nvSpPr>
         <p:spPr>
           <a:xfrm>
-            <a:off x="4306824" y="3227832"/>
-            <a:ext cx="73152" cy="256032"/>
+            <a:off x="4640580" y="3273552"/>
+            <a:ext cx="64008" cy="566928"/>
           </a:xfrm>
           <a:prstGeom prst="rect">
             <a:avLst/>
@@ -5494,14 +5893,14 @@
       </p:sp>
       <p:sp>
         <p:nvSpPr>
-          <p:cNvPr id="10" name="TextBox 9"/>
+          <p:cNvPr id="9" name="TextBox 8"/>
           <p:cNvSpPr txBox="1"/>
           <p:nvPr/>
         </p:nvSpPr>
         <p:spPr>
           <a:xfrm>
-            <a:off x="3154680" y="3547872"/>
-            <a:ext cx="2377440" cy="292608"/>
+            <a:off x="3529584" y="3886200"/>
+            <a:ext cx="2286000" cy="365760"/>
           </a:xfrm>
           <a:prstGeom prst="rect">
             <a:avLst/>
@@ -5516,7 +5915,7 @@
           <a:p>
             <a:pPr algn="ctr"/>
             <a:r>
-              <a:rPr sz="1500" b="0" i="0">
+              <a:rPr sz="1800" b="1" i="0">
                 <a:solidFill>
                   <a:srgbClr val="2E7D87"/>
                 </a:solidFill>
@@ -5529,14 +5928,14 @@
       </p:sp>
       <p:sp>
         <p:nvSpPr>
-          <p:cNvPr id="11" name="TextBox 10"/>
+          <p:cNvPr id="10" name="TextBox 9"/>
           <p:cNvSpPr txBox="1"/>
           <p:nvPr/>
         </p:nvSpPr>
         <p:spPr>
           <a:xfrm>
-            <a:off x="3154680" y="3822191"/>
-            <a:ext cx="2377440" cy="594360"/>
+            <a:off x="3529584" y="4343400"/>
+            <a:ext cx="2286000" cy="384048"/>
           </a:xfrm>
           <a:prstGeom prst="rect">
             <a:avLst/>
@@ -5551,39 +5950,27 @@
           <a:p>
             <a:pPr algn="ctr"/>
             <a:r>
-              <a:rPr sz="1800" b="1" i="0">
+              <a:rPr sz="1500" b="1" i="0">
                 <a:solidFill>
                   <a:srgbClr val="1A2744"/>
                 </a:solidFill>
                 <a:latin typeface="Calibri"/>
               </a:rPr>
-              <a:t>FIRST BEHAVIORAL</a:t>
-            </a:r>
-          </a:p>
-          <a:p>
-            <a:pPr algn="ctr"/>
-            <a:r>
-              <a:rPr sz="1800" b="1" i="0">
-                <a:solidFill>
-                  <a:srgbClr val="1A2744"/>
-                </a:solidFill>
-                <a:latin typeface="Calibri"/>
-              </a:rPr>
-              <a:t>SIGNALS</a:t>
-            </a:r>
-          </a:p>
-        </p:txBody>
-      </p:sp>
-      <p:sp>
-        <p:nvSpPr>
-          <p:cNvPr id="12" name="TextBox 11"/>
+              <a:t>FIRST BEHAVIORAL SIGNALS</a:t>
+            </a:r>
+          </a:p>
+        </p:txBody>
+      </p:sp>
+      <p:sp>
+        <p:nvSpPr>
+          <p:cNvPr id="11" name="TextBox 10"/>
           <p:cNvSpPr txBox="1"/>
           <p:nvPr/>
         </p:nvSpPr>
         <p:spPr>
           <a:xfrm>
-            <a:off x="3154680" y="4416552"/>
-            <a:ext cx="2377440" cy="1371600"/>
+            <a:off x="3529584" y="4800600"/>
+            <a:ext cx="2286000" cy="777240"/>
           </a:xfrm>
           <a:prstGeom prst="rect">
             <a:avLst/>
@@ -5598,51 +5985,29 @@
           <a:p>
             <a:pPr algn="ctr"/>
             <a:r>
-              <a:rPr sz="1500" b="0" i="0">
+              <a:rPr sz="1400" b="0" i="0">
                 <a:solidFill>
                   <a:srgbClr val="1A2744"/>
                 </a:solidFill>
                 <a:latin typeface="Calibri"/>
               </a:rPr>
-              <a:t>Managers functioning differently</a:t>
-            </a:r>
-          </a:p>
-          <a:p>
-            <a:pPr algn="ctr"/>
-            <a:r>
-              <a:rPr sz="1500" b="0" i="0">
-                <a:solidFill>
-                  <a:srgbClr val="1A2744"/>
-                </a:solidFill>
-                <a:latin typeface="Calibri"/>
-              </a:rPr>
-              <a:t>under pressure</a:t>
-            </a:r>
-          </a:p>
-          <a:p>
-            <a:pPr algn="ctr"/>
-            <a:r>
-              <a:rPr sz="1500" b="0" i="0">
-                <a:solidFill>
-                  <a:srgbClr val="1A2744"/>
-                </a:solidFill>
-                <a:latin typeface="Calibri"/>
-              </a:rPr>
-              <a:t>(if implementation proceeds)</a:t>
-            </a:r>
-          </a:p>
-        </p:txBody>
-      </p:sp>
-      <p:sp>
-        <p:nvSpPr>
-          <p:cNvPr id="13" name="Rectangle 12"/>
+              <a:t>Managers functioning differently
+under pressure
+(if implementation proceeds)</a:t>
+            </a:r>
+          </a:p>
+        </p:txBody>
+      </p:sp>
+      <p:sp>
+        <p:nvSpPr>
+          <p:cNvPr id="12" name="Rectangle 11"/>
           <p:cNvSpPr/>
           <p:nvPr/>
         </p:nvSpPr>
         <p:spPr>
           <a:xfrm>
-            <a:off x="7781544" y="3227832"/>
-            <a:ext cx="73152" cy="256032"/>
+            <a:off x="7484364" y="3273552"/>
+            <a:ext cx="64008" cy="566928"/>
           </a:xfrm>
           <a:prstGeom prst="rect">
             <a:avLst/>
@@ -5678,14 +6043,14 @@
       </p:sp>
       <p:sp>
         <p:nvSpPr>
-          <p:cNvPr id="14" name="TextBox 13"/>
+          <p:cNvPr id="13" name="TextBox 12"/>
           <p:cNvSpPr txBox="1"/>
           <p:nvPr/>
         </p:nvSpPr>
         <p:spPr>
           <a:xfrm>
-            <a:off x="6629400" y="1097280"/>
-            <a:ext cx="2377440" cy="292608"/>
+            <a:off x="6373368" y="1051560"/>
+            <a:ext cx="2286000" cy="365760"/>
           </a:xfrm>
           <a:prstGeom prst="rect">
             <a:avLst/>
@@ -5700,7 +6065,7 @@
           <a:p>
             <a:pPr algn="ctr"/>
             <a:r>
-              <a:rPr sz="1500" b="0" i="0">
+              <a:rPr sz="1800" b="1" i="0">
                 <a:solidFill>
                   <a:srgbClr val="2E7D87"/>
                 </a:solidFill>
@@ -5713,14 +6078,14 @@
       </p:sp>
       <p:sp>
         <p:nvSpPr>
-          <p:cNvPr id="15" name="TextBox 14"/>
+          <p:cNvPr id="14" name="TextBox 13"/>
           <p:cNvSpPr txBox="1"/>
           <p:nvPr/>
         </p:nvSpPr>
         <p:spPr>
           <a:xfrm>
-            <a:off x="6629400" y="1371600"/>
-            <a:ext cx="2377440" cy="594360"/>
+            <a:off x="6373368" y="1554480"/>
+            <a:ext cx="2286000" cy="384048"/>
           </a:xfrm>
           <a:prstGeom prst="rect">
             <a:avLst/>
@@ -5735,39 +6100,27 @@
           <a:p>
             <a:pPr algn="ctr"/>
             <a:r>
-              <a:rPr sz="1800" b="1" i="0">
+              <a:rPr sz="1500" b="1" i="0">
                 <a:solidFill>
                   <a:srgbClr val="1A2744"/>
                 </a:solidFill>
                 <a:latin typeface="Calibri"/>
               </a:rPr>
-              <a:t>TURNOVER</a:t>
-            </a:r>
-          </a:p>
-          <a:p>
-            <a:pPr algn="ctr"/>
-            <a:r>
-              <a:rPr sz="1800" b="1" i="0">
-                <a:solidFill>
-                  <a:srgbClr val="1A2744"/>
-                </a:solidFill>
-                <a:latin typeface="Calibri"/>
-              </a:rPr>
-              <a:t>SHIFT</a:t>
-            </a:r>
-          </a:p>
-        </p:txBody>
-      </p:sp>
-      <p:sp>
-        <p:nvSpPr>
-          <p:cNvPr id="16" name="TextBox 15"/>
+              <a:t>TURNOVER SHIFT</a:t>
+            </a:r>
+          </a:p>
+        </p:txBody>
+      </p:sp>
+      <p:sp>
+        <p:nvSpPr>
+          <p:cNvPr id="15" name="TextBox 14"/>
           <p:cNvSpPr txBox="1"/>
           <p:nvPr/>
         </p:nvSpPr>
         <p:spPr>
           <a:xfrm>
-            <a:off x="6629400" y="1901952"/>
-            <a:ext cx="2377440" cy="1371600"/>
+            <a:off x="6373368" y="2011680"/>
+            <a:ext cx="2286000" cy="777240"/>
           </a:xfrm>
           <a:prstGeom prst="rect">
             <a:avLst/>
@@ -5782,39 +6135,28 @@
           <a:p>
             <a:pPr algn="ctr"/>
             <a:r>
-              <a:rPr sz="1500" b="0" i="0">
+              <a:rPr sz="1400" b="0" i="0">
                 <a:solidFill>
                   <a:srgbClr val="1A2744"/>
                 </a:solidFill>
                 <a:latin typeface="Calibri"/>
               </a:rPr>
-              <a:t>Measurable reduction</a:t>
-            </a:r>
-          </a:p>
-          <a:p>
-            <a:pPr algn="ctr"/>
-            <a:r>
-              <a:rPr sz="1500" b="0" i="0">
-                <a:solidFill>
-                  <a:srgbClr val="1A2744"/>
-                </a:solidFill>
-                <a:latin typeface="Calibri"/>
-              </a:rPr>
-              <a:t>in departure rate</a:t>
-            </a:r>
-          </a:p>
-        </p:txBody>
-      </p:sp>
-      <p:sp>
-        <p:nvSpPr>
-          <p:cNvPr id="17" name="Rectangle 16"/>
+              <a:t>Measurable reduction
+in departure rate</a:t>
+            </a:r>
+          </a:p>
+        </p:txBody>
+      </p:sp>
+      <p:sp>
+        <p:nvSpPr>
+          <p:cNvPr id="16" name="Rectangle 15"/>
           <p:cNvSpPr/>
           <p:nvPr/>
         </p:nvSpPr>
         <p:spPr>
           <a:xfrm>
-            <a:off x="11256264" y="3227832"/>
-            <a:ext cx="73152" cy="256032"/>
+            <a:off x="10328148" y="3273552"/>
+            <a:ext cx="64008" cy="566928"/>
           </a:xfrm>
           <a:prstGeom prst="rect">
             <a:avLst/>
@@ -5850,14 +6192,14 @@
       </p:sp>
       <p:sp>
         <p:nvSpPr>
-          <p:cNvPr id="18" name="TextBox 17"/>
+          <p:cNvPr id="17" name="TextBox 16"/>
           <p:cNvSpPr txBox="1"/>
           <p:nvPr/>
         </p:nvSpPr>
         <p:spPr>
           <a:xfrm>
-            <a:off x="10104119" y="3547872"/>
-            <a:ext cx="2377440" cy="292608"/>
+            <a:off x="9217152" y="3886200"/>
+            <a:ext cx="2286000" cy="365760"/>
           </a:xfrm>
           <a:prstGeom prst="rect">
             <a:avLst/>
@@ -5872,7 +6214,7 @@
           <a:p>
             <a:pPr algn="ctr"/>
             <a:r>
-              <a:rPr sz="1500" b="0" i="0">
+              <a:rPr sz="1800" b="1" i="0">
                 <a:solidFill>
                   <a:srgbClr val="2E7D87"/>
                 </a:solidFill>
@@ -5885,14 +6227,14 @@
       </p:sp>
       <p:sp>
         <p:nvSpPr>
-          <p:cNvPr id="19" name="TextBox 18"/>
+          <p:cNvPr id="18" name="TextBox 17"/>
           <p:cNvSpPr txBox="1"/>
           <p:nvPr/>
         </p:nvSpPr>
         <p:spPr>
           <a:xfrm>
-            <a:off x="10104119" y="3822191"/>
-            <a:ext cx="2377440" cy="594360"/>
+            <a:off x="9217152" y="4343400"/>
+            <a:ext cx="2286000" cy="384048"/>
           </a:xfrm>
           <a:prstGeom prst="rect">
             <a:avLst/>
@@ -5907,39 +6249,27 @@
           <a:p>
             <a:pPr algn="ctr"/>
             <a:r>
-              <a:rPr sz="1800" b="1" i="0">
+              <a:rPr sz="1500" b="1" i="0">
                 <a:solidFill>
                   <a:srgbClr val="1A2744"/>
                 </a:solidFill>
                 <a:latin typeface="Calibri"/>
               </a:rPr>
-              <a:t>CULTURE</a:t>
-            </a:r>
-          </a:p>
-          <a:p>
-            <a:pPr algn="ctr"/>
-            <a:r>
-              <a:rPr sz="1800" b="1" i="0">
-                <a:solidFill>
-                  <a:srgbClr val="1A2744"/>
-                </a:solidFill>
-                <a:latin typeface="Calibri"/>
-              </a:rPr>
-              <a:t>THAT HOLDS</a:t>
-            </a:r>
-          </a:p>
-        </p:txBody>
-      </p:sp>
-      <p:sp>
-        <p:nvSpPr>
-          <p:cNvPr id="20" name="TextBox 19"/>
+              <a:t>CULTURE THAT HOLDS</a:t>
+            </a:r>
+          </a:p>
+        </p:txBody>
+      </p:sp>
+      <p:sp>
+        <p:nvSpPr>
+          <p:cNvPr id="19" name="TextBox 18"/>
           <p:cNvSpPr txBox="1"/>
           <p:nvPr/>
         </p:nvSpPr>
         <p:spPr>
           <a:xfrm>
-            <a:off x="10104119" y="4416552"/>
-            <a:ext cx="2377440" cy="1371600"/>
+            <a:off x="9217152" y="4800600"/>
+            <a:ext cx="2286000" cy="777240"/>
           </a:xfrm>
           <a:prstGeom prst="rect">
             <a:avLst/>
@@ -5954,51 +6284,29 @@
           <a:p>
             <a:pPr algn="ctr"/>
             <a:r>
-              <a:rPr sz="1500" b="0" i="0">
+              <a:rPr sz="1400" b="0" i="0">
                 <a:solidFill>
                   <a:srgbClr val="1A2744"/>
                 </a:solidFill>
                 <a:latin typeface="Calibri"/>
               </a:rPr>
-              <a:t>Norms self-transmitting to new</a:t>
-            </a:r>
-          </a:p>
-          <a:p>
-            <a:pPr algn="ctr"/>
-            <a:r>
-              <a:rPr sz="1500" b="0" i="0">
-                <a:solidFill>
-                  <a:srgbClr val="1A2744"/>
-                </a:solidFill>
-                <a:latin typeface="Calibri"/>
-              </a:rPr>
-              <a:t>employees without you</a:t>
-            </a:r>
-          </a:p>
-          <a:p>
-            <a:pPr algn="ctr"/>
-            <a:r>
-              <a:rPr sz="1500" b="0" i="0">
-                <a:solidFill>
-                  <a:srgbClr val="1A2744"/>
-                </a:solidFill>
-                <a:latin typeface="Calibri"/>
-              </a:rPr>
-              <a:t>maintaining it manually</a:t>
-            </a:r>
-          </a:p>
-        </p:txBody>
-      </p:sp>
-      <p:sp>
-        <p:nvSpPr>
-          <p:cNvPr id="21" name="TextBox 20"/>
+              <a:t>Norms self-transmitting to new
+employees without you
+maintaining it manually</a:t>
+            </a:r>
+          </a:p>
+        </p:txBody>
+      </p:sp>
+      <p:sp>
+        <p:nvSpPr>
+          <p:cNvPr id="20" name="TextBox 19"/>
           <p:cNvSpPr txBox="1"/>
           <p:nvPr/>
         </p:nvSpPr>
         <p:spPr>
           <a:xfrm>
-            <a:off x="365760" y="6263640"/>
-            <a:ext cx="11430000" cy="438912"/>
+            <a:off x="457200" y="6080760"/>
+            <a:ext cx="11274552" cy="548640"/>
           </a:xfrm>
           <a:prstGeom prst="rect">
             <a:avLst/>
@@ -6019,7 +6327,7 @@
                 </a:solidFill>
                 <a:latin typeface="Calibri"/>
               </a:rPr>
-              <a:t>This isn’t fast. What’s faster is not doing it — and you’ve already seen what that costs.</a:t>
+              <a:t>This isn't fast. What's faster is not doing it — and you've already seen what that costs.</a:t>
             </a:r>
           </a:p>
         </p:txBody>
@@ -6058,8 +6366,8 @@
         </p:nvSpPr>
         <p:spPr>
           <a:xfrm>
-            <a:off x="201168" y="91440"/>
-            <a:ext cx="502920" cy="274320"/>
+            <a:off x="457200" y="365760"/>
+            <a:ext cx="11274552" cy="594360"/>
           </a:xfrm>
           <a:prstGeom prst="rect">
             <a:avLst/>
@@ -6074,41 +6382,6 @@
           <a:p>
             <a:pPr algn="l"/>
             <a:r>
-              <a:rPr sz="1300" b="1" i="0">
-                <a:solidFill>
-                  <a:srgbClr val="2E7D87"/>
-                </a:solidFill>
-                <a:latin typeface="Calibri"/>
-              </a:rPr>
-              <a:t>06</a:t>
-            </a:r>
-          </a:p>
-        </p:txBody>
-      </p:sp>
-      <p:sp>
-        <p:nvSpPr>
-          <p:cNvPr id="3" name="TextBox 2"/>
-          <p:cNvSpPr txBox="1"/>
-          <p:nvPr/>
-        </p:nvSpPr>
-        <p:spPr>
-          <a:xfrm>
-            <a:off x="365760" y="182880"/>
-            <a:ext cx="11430000" cy="530352"/>
-          </a:xfrm>
-          <a:prstGeom prst="rect">
-            <a:avLst/>
-          </a:prstGeom>
-          <a:noFill/>
-        </p:spPr>
-        <p:txBody>
-          <a:bodyPr wrap="square">
-            <a:spAutoFit/>
-          </a:bodyPr>
-          <a:lstStyle/>
-          <a:p>
-            <a:pPr algn="l"/>
-            <a:r>
               <a:rPr sz="3400" b="1" i="0">
                 <a:solidFill>
                   <a:srgbClr val="1A2744"/>
@@ -6122,20 +6395,20 @@
       </p:sp>
       <p:sp>
         <p:nvSpPr>
-          <p:cNvPr id="4" name="Rectangle 3"/>
+          <p:cNvPr id="3" name="Rectangle 2"/>
           <p:cNvSpPr/>
           <p:nvPr/>
         </p:nvSpPr>
         <p:spPr>
           <a:xfrm>
-            <a:off x="6007608" y="822960"/>
-            <a:ext cx="36576" cy="5577840"/>
+            <a:off x="6094476" y="1143000"/>
+            <a:ext cx="22860" cy="4572000"/>
           </a:xfrm>
           <a:prstGeom prst="rect">
             <a:avLst/>
           </a:prstGeom>
           <a:solidFill>
-            <a:srgbClr val="2E7D87"/>
+            <a:srgbClr val="CCCCCC"/>
           </a:solidFill>
           <a:ln>
             <a:noFill/>
@@ -6165,14 +6438,14 @@
       </p:sp>
       <p:sp>
         <p:nvSpPr>
-          <p:cNvPr id="5" name="TextBox 4"/>
+          <p:cNvPr id="4" name="TextBox 3"/>
           <p:cNvSpPr txBox="1"/>
           <p:nvPr/>
         </p:nvSpPr>
         <p:spPr>
           <a:xfrm>
-            <a:off x="457200" y="896112"/>
-            <a:ext cx="5303520" cy="502920"/>
+            <a:off x="457200" y="1143000"/>
+            <a:ext cx="5029200" cy="502920"/>
           </a:xfrm>
           <a:prstGeom prst="rect">
             <a:avLst/>
@@ -6200,14 +6473,14 @@
       </p:sp>
       <p:sp>
         <p:nvSpPr>
-          <p:cNvPr id="6" name="TextBox 5"/>
+          <p:cNvPr id="5" name="TextBox 4"/>
           <p:cNvSpPr txBox="1"/>
           <p:nvPr/>
         </p:nvSpPr>
         <p:spPr>
           <a:xfrm>
-            <a:off x="6263640" y="896112"/>
-            <a:ext cx="5577840" cy="502920"/>
+            <a:off x="457200" y="1737360"/>
+            <a:ext cx="5029200" cy="3840480"/>
           </a:xfrm>
           <a:prstGeom prst="rect">
             <a:avLst/>
@@ -6222,27 +6495,63 @@
           <a:p>
             <a:pPr algn="ctr"/>
             <a:r>
-              <a:rPr sz="2400" b="1" i="0">
-                <a:solidFill>
-                  <a:srgbClr val="2E7D87"/>
+              <a:rPr sz="2200" b="0" i="0">
+                <a:solidFill>
+                  <a:srgbClr val="1A2744"/>
                 </a:solidFill>
                 <a:latin typeface="Calibri"/>
               </a:rPr>
-              <a:t>What this IS</a:t>
-            </a:r>
-          </a:p>
-        </p:txBody>
-      </p:sp>
-      <p:sp>
-        <p:nvSpPr>
-          <p:cNvPr id="7" name="TextBox 6"/>
+              <a:t>An evaluation of how they manage</a:t>
+            </a:r>
+          </a:p>
+          <a:p>
+            <a:pPr algn="ctr"/>
+            <a:r>
+              <a:rPr sz="2200" b="0" i="0">
+                <a:solidFill>
+                  <a:srgbClr val="1A2744"/>
+                </a:solidFill>
+                <a:latin typeface="Calibri"/>
+              </a:rPr>
+              <a:t>An HR audit or compliance review</a:t>
+            </a:r>
+          </a:p>
+          <a:p>
+            <a:pPr algn="ctr"/>
+            <a:r>
+              <a:rPr sz="2200" b="0" i="0">
+                <a:solidFill>
+                  <a:srgbClr val="1A2744"/>
+                </a:solidFill>
+                <a:latin typeface="Calibri"/>
+              </a:rPr>
+              <a:t>Individual data going to you</a:t>
+            </a:r>
+          </a:p>
+          <a:p>
+            <a:pPr algn="ctr"/>
+            <a:r>
+              <a:rPr sz="2200" b="0" i="0">
+                <a:solidFill>
+                  <a:srgbClr val="1A2744"/>
+                </a:solidFill>
+                <a:latin typeface="Calibri"/>
+              </a:rPr>
+              <a:t>Supervision by an outside person</a:t>
+            </a:r>
+          </a:p>
+        </p:txBody>
+      </p:sp>
+      <p:sp>
+        <p:nvSpPr>
+          <p:cNvPr id="6" name="TextBox 5"/>
           <p:cNvSpPr txBox="1"/>
           <p:nvPr/>
         </p:nvSpPr>
         <p:spPr>
           <a:xfrm>
-            <a:off x="502920" y="1572768"/>
-            <a:ext cx="5257800" cy="877824"/>
+            <a:off x="6702552" y="1143000"/>
+            <a:ext cx="5029200" cy="502920"/>
           </a:xfrm>
           <a:prstGeom prst="rect">
             <a:avLst/>
@@ -6255,29 +6564,29 @@
           </a:bodyPr>
           <a:lstStyle/>
           <a:p>
-            <a:pPr algn="l"/>
-            <a:r>
-              <a:rPr sz="2200" b="0" i="0">
-                <a:solidFill>
-                  <a:srgbClr val="1A2744"/>
+            <a:pPr algn="ctr"/>
+            <a:r>
+              <a:rPr sz="2400" b="1" i="0">
+                <a:solidFill>
+                  <a:srgbClr val="2E7D87"/>
                 </a:solidFill>
                 <a:latin typeface="Calibri"/>
               </a:rPr>
-              <a:t>An evaluation of how they manage</a:t>
-            </a:r>
-          </a:p>
-        </p:txBody>
-      </p:sp>
-      <p:sp>
-        <p:nvSpPr>
-          <p:cNvPr id="8" name="TextBox 7"/>
+              <a:t>What this IS</a:t>
+            </a:r>
+          </a:p>
+        </p:txBody>
+      </p:sp>
+      <p:sp>
+        <p:nvSpPr>
+          <p:cNvPr id="7" name="TextBox 6"/>
           <p:cNvSpPr txBox="1"/>
           <p:nvPr/>
         </p:nvSpPr>
         <p:spPr>
           <a:xfrm>
-            <a:off x="502920" y="2542032"/>
-            <a:ext cx="5257800" cy="877824"/>
+            <a:off x="6702552" y="1737360"/>
+            <a:ext cx="5029200" cy="3840480"/>
           </a:xfrm>
           <a:prstGeom prst="rect">
             <a:avLst/>
@@ -6290,7 +6599,7 @@
           </a:bodyPr>
           <a:lstStyle/>
           <a:p>
-            <a:pPr algn="l"/>
+            <a:pPr algn="ctr"/>
             <a:r>
               <a:rPr sz="2200" b="0" i="0">
                 <a:solidFill>
@@ -6298,34 +6607,11 @@
                 </a:solidFill>
                 <a:latin typeface="Calibri"/>
               </a:rPr>
-              <a:t>An HR audit or compliance review</a:t>
-            </a:r>
-          </a:p>
-        </p:txBody>
-      </p:sp>
-      <p:sp>
-        <p:nvSpPr>
-          <p:cNvPr id="9" name="TextBox 8"/>
-          <p:cNvSpPr txBox="1"/>
-          <p:nvPr/>
-        </p:nvSpPr>
-        <p:spPr>
-          <a:xfrm>
-            <a:off x="502920" y="3511296"/>
-            <a:ext cx="5257800" cy="877824"/>
-          </a:xfrm>
-          <a:prstGeom prst="rect">
-            <a:avLst/>
-          </a:prstGeom>
-          <a:noFill/>
-        </p:spPr>
-        <p:txBody>
-          <a:bodyPr wrap="square">
-            <a:spAutoFit/>
-          </a:bodyPr>
-          <a:lstStyle/>
-          <a:p>
-            <a:pPr algn="l"/>
+              <a:t>Private development — their data stays with them</a:t>
+            </a:r>
+          </a:p>
+          <a:p>
+            <a:pPr algn="ctr"/>
             <a:r>
               <a:rPr sz="2200" b="0" i="0">
                 <a:solidFill>
@@ -6333,163 +6619,11 @@
                 </a:solidFill>
                 <a:latin typeface="Calibri"/>
               </a:rPr>
-              <a:t>Individual data going to you</a:t>
-            </a:r>
-          </a:p>
-        </p:txBody>
-      </p:sp>
-      <p:sp>
-        <p:nvSpPr>
-          <p:cNvPr id="10" name="TextBox 9"/>
-          <p:cNvSpPr txBox="1"/>
-          <p:nvPr/>
-        </p:nvSpPr>
-        <p:spPr>
-          <a:xfrm>
-            <a:off x="502920" y="4480560"/>
-            <a:ext cx="5257800" cy="877824"/>
-          </a:xfrm>
-          <a:prstGeom prst="rect">
-            <a:avLst/>
-          </a:prstGeom>
-          <a:noFill/>
-        </p:spPr>
-        <p:txBody>
-          <a:bodyPr wrap="square">
-            <a:spAutoFit/>
-          </a:bodyPr>
-          <a:lstStyle/>
-          <a:p>
-            <a:pPr algn="l"/>
-            <a:r>
-              <a:rPr sz="2200" b="0" i="0">
-                <a:solidFill>
-                  <a:srgbClr val="1A2744"/>
-                </a:solidFill>
-                <a:latin typeface="Calibri"/>
-              </a:rPr>
-              <a:t>Supervision by an outside person</a:t>
-            </a:r>
-          </a:p>
-        </p:txBody>
-      </p:sp>
-      <p:sp>
-        <p:nvSpPr>
-          <p:cNvPr id="11" name="TextBox 10"/>
-          <p:cNvSpPr txBox="1"/>
-          <p:nvPr/>
-        </p:nvSpPr>
-        <p:spPr>
-          <a:xfrm>
-            <a:off x="6263640" y="1572768"/>
-            <a:ext cx="5577840" cy="877824"/>
-          </a:xfrm>
-          <a:prstGeom prst="rect">
-            <a:avLst/>
-          </a:prstGeom>
-          <a:noFill/>
-        </p:spPr>
-        <p:txBody>
-          <a:bodyPr wrap="square">
-            <a:spAutoFit/>
-          </a:bodyPr>
-          <a:lstStyle/>
-          <a:p>
-            <a:pPr algn="l"/>
-            <a:r>
-              <a:rPr sz="2200" b="0" i="0">
-                <a:solidFill>
-                  <a:srgbClr val="1A2744"/>
-                </a:solidFill>
-                <a:latin typeface="Calibri"/>
-              </a:rPr>
-              <a:t>Private development —</a:t>
-            </a:r>
-          </a:p>
-          <a:p>
-            <a:pPr algn="l"/>
-            <a:r>
-              <a:rPr sz="2200" b="0" i="0">
-                <a:solidFill>
-                  <a:srgbClr val="1A2744"/>
-                </a:solidFill>
-                <a:latin typeface="Calibri"/>
-              </a:rPr>
-              <a:t>their data stays with them</a:t>
-            </a:r>
-          </a:p>
-        </p:txBody>
-      </p:sp>
-      <p:sp>
-        <p:nvSpPr>
-          <p:cNvPr id="12" name="TextBox 11"/>
-          <p:cNvSpPr txBox="1"/>
-          <p:nvPr/>
-        </p:nvSpPr>
-        <p:spPr>
-          <a:xfrm>
-            <a:off x="6263640" y="2542032"/>
-            <a:ext cx="5577840" cy="877824"/>
-          </a:xfrm>
-          <a:prstGeom prst="rect">
-            <a:avLst/>
-          </a:prstGeom>
-          <a:noFill/>
-        </p:spPr>
-        <p:txBody>
-          <a:bodyPr wrap="square">
-            <a:spAutoFit/>
-          </a:bodyPr>
-          <a:lstStyle/>
-          <a:p>
-            <a:pPr algn="l"/>
-            <a:r>
-              <a:rPr sz="2200" b="0" i="0">
-                <a:solidFill>
-                  <a:srgbClr val="1A2744"/>
-                </a:solidFill>
-                <a:latin typeface="Calibri"/>
-              </a:rPr>
-              <a:t>A picture of how the team</a:t>
-            </a:r>
-          </a:p>
-          <a:p>
-            <a:pPr algn="l"/>
-            <a:r>
-              <a:rPr sz="2200" b="0" i="0">
-                <a:solidFill>
-                  <a:srgbClr val="1A2744"/>
-                </a:solidFill>
-                <a:latin typeface="Calibri"/>
-              </a:rPr>
-              <a:t>functions collectively</a:t>
-            </a:r>
-          </a:p>
-        </p:txBody>
-      </p:sp>
-      <p:sp>
-        <p:nvSpPr>
-          <p:cNvPr id="13" name="TextBox 12"/>
-          <p:cNvSpPr txBox="1"/>
-          <p:nvPr/>
-        </p:nvSpPr>
-        <p:spPr>
-          <a:xfrm>
-            <a:off x="6263640" y="3511296"/>
-            <a:ext cx="5577840" cy="877824"/>
-          </a:xfrm>
-          <a:prstGeom prst="rect">
-            <a:avLst/>
-          </a:prstGeom>
-          <a:noFill/>
-        </p:spPr>
-        <p:txBody>
-          <a:bodyPr wrap="square">
-            <a:spAutoFit/>
-          </a:bodyPr>
-          <a:lstStyle/>
-          <a:p>
-            <a:pPr algn="l"/>
+              <a:t>A picture of how the team functions collectively</a:t>
+            </a:r>
+          </a:p>
+          <a:p>
+            <a:pPr algn="ctr"/>
             <a:r>
               <a:rPr sz="2200" b="0" i="0">
                 <a:solidFill>
@@ -6500,31 +6634,8 @@
               <a:t>Tools to do their jobs better</a:t>
             </a:r>
           </a:p>
-        </p:txBody>
-      </p:sp>
-      <p:sp>
-        <p:nvSpPr>
-          <p:cNvPr id="14" name="TextBox 13"/>
-          <p:cNvSpPr txBox="1"/>
-          <p:nvPr/>
-        </p:nvSpPr>
-        <p:spPr>
-          <a:xfrm>
-            <a:off x="6263640" y="4480560"/>
-            <a:ext cx="5577840" cy="877824"/>
-          </a:xfrm>
-          <a:prstGeom prst="rect">
-            <a:avLst/>
-          </a:prstGeom>
-          <a:noFill/>
-        </p:spPr>
-        <p:txBody>
-          <a:bodyPr wrap="square">
-            <a:spAutoFit/>
-          </a:bodyPr>
-          <a:lstStyle/>
-          <a:p>
-            <a:pPr algn="l"/>
+          <a:p>
+            <a:pPr algn="ctr"/>
             <a:r>
               <a:rPr sz="2200" b="0" i="0">
                 <a:solidFill>
@@ -6539,14 +6650,14 @@
       </p:sp>
       <p:sp>
         <p:nvSpPr>
-          <p:cNvPr id="15" name="TextBox 14"/>
+          <p:cNvPr id="8" name="TextBox 7"/>
           <p:cNvSpPr txBox="1"/>
           <p:nvPr/>
         </p:nvSpPr>
         <p:spPr>
           <a:xfrm>
-            <a:off x="365760" y="6263640"/>
-            <a:ext cx="11430000" cy="438912"/>
+            <a:off x="457200" y="6080760"/>
+            <a:ext cx="11274552" cy="548640"/>
           </a:xfrm>
           <a:prstGeom prst="rect">
             <a:avLst/>
@@ -6898,4 +7009,324 @@
   </a:objectDefaults>
   <a:extraClrSchemeLst/>
 </a:theme>
+</file>
+
+<file path=ppt/theme/theme2.xml><?xml version="1.0" encoding="utf-8"?>
+<a:theme xmlns:a="http://schemas.openxmlformats.org/drawingml/2006/main" name="Office Theme">
+  <a:themeElements>
+    <a:clrScheme name="Office">
+      <a:dk1>
+        <a:sysClr val="windowText" lastClr="000000"/>
+      </a:dk1>
+      <a:lt1>
+        <a:sysClr val="window" lastClr="FFFFFF"/>
+      </a:lt1>
+      <a:dk2>
+        <a:srgbClr val="1F497D"/>
+      </a:dk2>
+      <a:lt2>
+        <a:srgbClr val="EEECE1"/>
+      </a:lt2>
+      <a:accent1>
+        <a:srgbClr val="4F81BD"/>
+      </a:accent1>
+      <a:accent2>
+        <a:srgbClr val="C0504D"/>
+      </a:accent2>
+      <a:accent3>
+        <a:srgbClr val="9BBB59"/>
+      </a:accent3>
+      <a:accent4>
+        <a:srgbClr val="8064A2"/>
+      </a:accent4>
+      <a:accent5>
+        <a:srgbClr val="4BACC6"/>
+      </a:accent5>
+      <a:accent6>
+        <a:srgbClr val="F79646"/>
+      </a:accent6>
+      <a:hlink>
+        <a:srgbClr val="0000FF"/>
+      </a:hlink>
+      <a:folHlink>
+        <a:srgbClr val="800080"/>
+      </a:folHlink>
+    </a:clrScheme>
+    <a:fontScheme name="Office">
+      <a:majorFont>
+        <a:latin typeface="Calibri"/>
+        <a:ea typeface=""/>
+        <a:cs typeface=""/>
+        <a:font script="Jpan" typeface="ＭＳ Ｐゴシック"/>
+        <a:font script="Hang" typeface="맑은 고딕"/>
+        <a:font script="Hans" typeface="宋体"/>
+        <a:font script="Hant" typeface="新細明體"/>
+        <a:font script="Arab" typeface="Times New Roman"/>
+        <a:font script="Hebr" typeface="Times New Roman"/>
+        <a:font script="Thai" typeface="Angsana New"/>
+        <a:font script="Ethi" typeface="Nyala"/>
+        <a:font script="Beng" typeface="Vrinda"/>
+        <a:font script="Gujr" typeface="Shruti"/>
+        <a:font script="Khmr" typeface="MoolBoran"/>
+        <a:font script="Knda" typeface="Tunga"/>
+        <a:font script="Guru" typeface="Raavi"/>
+        <a:font script="Cans" typeface="Euphemia"/>
+        <a:font script="Cher" typeface="Plantagenet Cherokee"/>
+        <a:font script="Yiii" typeface="Microsoft Yi Baiti"/>
+        <a:font script="Tibt" typeface="Microsoft Himalaya"/>
+        <a:font script="Thaa" typeface="MV Boli"/>
+        <a:font script="Deva" typeface="Mangal"/>
+        <a:font script="Telu" typeface="Gautami"/>
+        <a:font script="Taml" typeface="Latha"/>
+        <a:font script="Syrc" typeface="Estrangelo Edessa"/>
+        <a:font script="Orya" typeface="Kalinga"/>
+        <a:font script="Mlym" typeface="Kartika"/>
+        <a:font script="Laoo" typeface="DokChampa"/>
+        <a:font script="Sinh" typeface="Iskoola Pota"/>
+        <a:font script="Mong" typeface="Mongolian Baiti"/>
+        <a:font script="Viet" typeface="Times New Roman"/>
+        <a:font script="Uigh" typeface="Microsoft Uighur"/>
+        <a:font script="Geor" typeface="Sylfaen"/>
+      </a:majorFont>
+      <a:minorFont>
+        <a:latin typeface="Calibri"/>
+        <a:ea typeface=""/>
+        <a:cs typeface=""/>
+        <a:font script="Jpan" typeface="ＭＳ Ｐゴシック"/>
+        <a:font script="Hang" typeface="맑은 고딕"/>
+        <a:font script="Hans" typeface="宋体"/>
+        <a:font script="Hant" typeface="新細明體"/>
+        <a:font script="Arab" typeface="Arial"/>
+        <a:font script="Hebr" typeface="Arial"/>
+        <a:font script="Thai" typeface="Cordia New"/>
+        <a:font script="Ethi" typeface="Nyala"/>
+        <a:font script="Beng" typeface="Vrinda"/>
+        <a:font script="Gujr" typeface="Shruti"/>
+        <a:font script="Khmr" typeface="DaunPenh"/>
+        <a:font script="Knda" typeface="Tunga"/>
+        <a:font script="Guru" typeface="Raavi"/>
+        <a:font script="Cans" typeface="Euphemia"/>
+        <a:font script="Cher" typeface="Plantagenet Cherokee"/>
+        <a:font script="Yiii" typeface="Microsoft Yi Baiti"/>
+        <a:font script="Tibt" typeface="Microsoft Himalaya"/>
+        <a:font script="Thaa" typeface="MV Boli"/>
+        <a:font script="Deva" typeface="Mangal"/>
+        <a:font script="Telu" typeface="Gautami"/>
+        <a:font script="Taml" typeface="Latha"/>
+        <a:font script="Syrc" typeface="Estrangelo Edessa"/>
+        <a:font script="Orya" typeface="Kalinga"/>
+        <a:font script="Mlym" typeface="Kartika"/>
+        <a:font script="Laoo" typeface="DokChampa"/>
+        <a:font script="Sinh" typeface="Iskoola Pota"/>
+        <a:font script="Mong" typeface="Mongolian Baiti"/>
+        <a:font script="Viet" typeface="Arial"/>
+        <a:font script="Uigh" typeface="Microsoft Uighur"/>
+        <a:font script="Geor" typeface="Sylfaen"/>
+      </a:minorFont>
+    </a:fontScheme>
+    <a:fmtScheme name="Office">
+      <a:fillStyleLst>
+        <a:solidFill>
+          <a:schemeClr val="phClr"/>
+        </a:solidFill>
+        <a:gradFill rotWithShape="1">
+          <a:gsLst>
+            <a:gs pos="0">
+              <a:schemeClr val="phClr">
+                <a:tint val="50000"/>
+                <a:satMod val="300000"/>
+              </a:schemeClr>
+            </a:gs>
+            <a:gs pos="35000">
+              <a:schemeClr val="phClr">
+                <a:tint val="37000"/>
+                <a:satMod val="300000"/>
+              </a:schemeClr>
+            </a:gs>
+            <a:gs pos="100000">
+              <a:schemeClr val="phClr">
+                <a:tint val="15000"/>
+                <a:satMod val="350000"/>
+              </a:schemeClr>
+            </a:gs>
+          </a:gsLst>
+          <a:lin ang="16200000" scaled="1"/>
+        </a:gradFill>
+        <a:gradFill rotWithShape="1">
+          <a:gsLst>
+            <a:gs pos="0">
+              <a:schemeClr val="phClr">
+                <a:tint val="100000"/>
+                <a:shade val="100000"/>
+                <a:satMod val="130000"/>
+              </a:schemeClr>
+            </a:gs>
+            <a:gs pos="100000">
+              <a:schemeClr val="phClr">
+                <a:tint val="50000"/>
+                <a:shade val="100000"/>
+                <a:satMod val="350000"/>
+              </a:schemeClr>
+            </a:gs>
+          </a:gsLst>
+          <a:lin ang="16200000" scaled="0"/>
+        </a:gradFill>
+      </a:fillStyleLst>
+      <a:lnStyleLst>
+        <a:ln w="9525" cap="flat" cmpd="sng" algn="ctr">
+          <a:solidFill>
+            <a:schemeClr val="phClr">
+              <a:shade val="95000"/>
+              <a:satMod val="105000"/>
+            </a:schemeClr>
+          </a:solidFill>
+          <a:prstDash val="solid"/>
+        </a:ln>
+        <a:ln w="25400" cap="flat" cmpd="sng" algn="ctr">
+          <a:solidFill>
+            <a:schemeClr val="phClr"/>
+          </a:solidFill>
+          <a:prstDash val="solid"/>
+        </a:ln>
+        <a:ln w="38100" cap="flat" cmpd="sng" algn="ctr">
+          <a:solidFill>
+            <a:schemeClr val="phClr"/>
+          </a:solidFill>
+          <a:prstDash val="solid"/>
+        </a:ln>
+      </a:lnStyleLst>
+      <a:effectStyleLst>
+        <a:effectStyle>
+          <a:effectLst>
+            <a:outerShdw blurRad="40000" dist="20000" dir="5400000" rotWithShape="0">
+              <a:srgbClr val="000000">
+                <a:alpha val="38000"/>
+              </a:srgbClr>
+            </a:outerShdw>
+          </a:effectLst>
+        </a:effectStyle>
+        <a:effectStyle>
+          <a:effectLst>
+            <a:outerShdw blurRad="40000" dist="23000" dir="5400000" rotWithShape="0">
+              <a:srgbClr val="000000">
+                <a:alpha val="35000"/>
+              </a:srgbClr>
+            </a:outerShdw>
+          </a:effectLst>
+        </a:effectStyle>
+        <a:effectStyle>
+          <a:effectLst>
+            <a:outerShdw blurRad="40000" dist="23000" dir="5400000" rotWithShape="0">
+              <a:srgbClr val="000000">
+                <a:alpha val="35000"/>
+              </a:srgbClr>
+            </a:outerShdw>
+          </a:effectLst>
+          <a:scene3d>
+            <a:camera prst="orthographicFront">
+              <a:rot lat="0" lon="0" rev="0"/>
+            </a:camera>
+            <a:lightRig rig="threePt" dir="t">
+              <a:rot lat="0" lon="0" rev="1200000"/>
+            </a:lightRig>
+          </a:scene3d>
+          <a:sp3d>
+            <a:bevelT w="63500" h="25400"/>
+          </a:sp3d>
+        </a:effectStyle>
+      </a:effectStyleLst>
+      <a:bgFillStyleLst>
+        <a:solidFill>
+          <a:schemeClr val="phClr"/>
+        </a:solidFill>
+        <a:gradFill rotWithShape="1">
+          <a:gsLst>
+            <a:gs pos="0">
+              <a:schemeClr val="phClr">
+                <a:tint val="40000"/>
+                <a:satMod val="350000"/>
+              </a:schemeClr>
+            </a:gs>
+            <a:gs pos="40000">
+              <a:schemeClr val="phClr">
+                <a:tint val="45000"/>
+                <a:shade val="99000"/>
+                <a:satMod val="350000"/>
+              </a:schemeClr>
+            </a:gs>
+            <a:gs pos="100000">
+              <a:schemeClr val="phClr">
+                <a:shade val="20000"/>
+                <a:satMod val="255000"/>
+              </a:schemeClr>
+            </a:gs>
+          </a:gsLst>
+          <a:path path="circle">
+            <a:fillToRect l="50000" t="-80000" r="50000" b="180000"/>
+          </a:path>
+        </a:gradFill>
+        <a:gradFill rotWithShape="1">
+          <a:gsLst>
+            <a:gs pos="0">
+              <a:schemeClr val="phClr">
+                <a:tint val="80000"/>
+                <a:satMod val="300000"/>
+              </a:schemeClr>
+            </a:gs>
+            <a:gs pos="100000">
+              <a:schemeClr val="phClr">
+                <a:shade val="30000"/>
+                <a:satMod val="200000"/>
+              </a:schemeClr>
+            </a:gs>
+          </a:gsLst>
+          <a:path path="circle">
+            <a:fillToRect l="50000" t="50000" r="50000" b="50000"/>
+          </a:path>
+        </a:gradFill>
+      </a:bgFillStyleLst>
+    </a:fmtScheme>
+  </a:themeElements>
+  <a:objectDefaults>
+    <a:spDef>
+      <a:spPr/>
+      <a:bodyPr/>
+      <a:lstStyle/>
+      <a:style>
+        <a:lnRef idx="1">
+          <a:schemeClr val="accent1"/>
+        </a:lnRef>
+        <a:fillRef idx="3">
+          <a:schemeClr val="accent1"/>
+        </a:fillRef>
+        <a:effectRef idx="2">
+          <a:schemeClr val="accent1"/>
+        </a:effectRef>
+        <a:fontRef idx="minor">
+          <a:schemeClr val="lt1"/>
+        </a:fontRef>
+      </a:style>
+    </a:spDef>
+    <a:lnDef>
+      <a:spPr/>
+      <a:bodyPr/>
+      <a:lstStyle/>
+      <a:style>
+        <a:lnRef idx="2">
+          <a:schemeClr val="accent1"/>
+        </a:lnRef>
+        <a:fillRef idx="0">
+          <a:schemeClr val="accent1"/>
+        </a:fillRef>
+        <a:effectRef idx="1">
+          <a:schemeClr val="accent1"/>
+        </a:effectRef>
+        <a:fontRef idx="minor">
+          <a:schemeClr val="tx1"/>
+        </a:fontRef>
+      </a:style>
+    </a:lnDef>
+  </a:objectDefaults>
+  <a:extraClrSchemeLst/>
+</a:theme>
 </file>
</xml_diff>

<commit_message>
vault backup: 2026-06-02 16:38:36
</commit_message>
<xml_diff>
--- a/Coaching/Business Advisory Services/A001/A001 — Presentation Deck 3.pptx
+++ b/Coaching/Business Advisory Services/A001/A001 — Presentation Deck 3.pptx
@@ -507,7 +507,7 @@
           <a:lstStyle/>
           <a:p>
             <a:r>
-              <a:t>"You've already named this — you identified at [coffee shop] that the behavior is coming from the environment, not the character of your people. This is why training doesn't stick. It changes what people know. It doesn't change the conditions that activated the pattern in the first place. When the manager walks back into the same environment, the same conditions produce the same behavior. What's different here is that we work at the level where the pattern is actually produced."</a:t>
+              <a:t>"You've already named this — you identified at [coffee shop] that the behavior is coming from the environment, not the character of your people. That's exactly right, and it's also why what you've tried hasn't held. Standard training changes what people know. It doesn't touch the conditions that produced the behavior in the first place. When your manager walks back into the same environment, the same conditions produce the same result. What's different here is the level of the intervention. We work where the pattern is actually made."</a:t>
             </a:r>
           </a:p>
           <a:p/>
@@ -593,13 +593,13 @@
           <a:lstStyle/>
           <a:p>
             <a:r>
-              <a:t>"This is the chain. Structural conditions in the operation — how authority works, how mistakes get handled, how much certainty people have about what's expected — shape how managers experience their environment day to day. That shapes how managers show up with their teams. That shapes how employees experience their environment. And what you see is in the fourth box: the conflict, the avoidance, the turnover. The fifth box is what it costs you. You're watching the last two boxes. The work is in the first three."</a:t>
+              <a:t>"This is why the same situations keep producing the same results. Structural conditions in the operation — how authority flows, how mistakes get handled, how much clarity people have — shape how your managers experience the environment every day. That shapes how your managers show up with their teams. That shapes what your employees experience. And what you're watching is in the fourth box. What it's costing you is the fifth. You've been focused on boxes four and five. The work is in the first three."</a:t>
             </a:r>
           </a:p>
           <a:p/>
           <a:p>
             <a:r>
-              <a:t>Deploy when: Owner asks HOW environment produces behavior; OR after a specific incident</a:t>
+              <a:t>Deploy when: Owner asks HOW environment produces behavior; OR after describing a specific incident</a:t>
             </a:r>
           </a:p>
           <a:p>
@@ -679,7 +679,7 @@
           <a:lstStyle/>
           <a:p>
             <a:r>
-              <a:t>"At your scale, you're replacing roughly 300 people a year. At $3,000 to $5,000 per replacement — and those are conservative numbers for hospitality — that's $1.2 million annually, just in replacement cost. That doesn't count what it costs while the position is vacant, what it costs to ramp a new hire, or what it costs to your guest experience when your team is in constant turnover. The Phase 1 investment is $28,000. That pays for itself before you'd notice the savings."</a:t>
+              <a:t>"At your scale, roughly 300 replacements a year. At $3,000 to $5,000 per replacement — that's the conservative range for hospitality — you're at $1.2 million annually, before you factor in the productivity gap while a position is vacant, the ramp time on a new hire, or what constant turnover does to the guest experience. The Phase 1 investment is $28,000. If turnover drops even two or three percent, it's paid for before you'd feel it. The question isn't whether you can afford to do this. You've already been paying for not doing it."</a:t>
             </a:r>
           </a:p>
           <a:p/>
@@ -765,7 +765,7 @@
           <a:lstStyle/>
           <a:p>
             <a:r>
-              <a:t>"Three things come out of Phase 1. First, a behavioral profile for each leader — what their patterns are, what activates them, and what their specific development path looks like. Second, a team map — how the management team functions collectively, and what in the structure is contributing to the patterns. Third, structural recommendations — specific things in how you're running the environment that are driving what you're seeing. Each one connects to a specific decision. At the end of Phase 1 you decide whether you want to move to implementation."</a:t>
+              <a:t>"Three deliverables at the end of Phase 1. A behavioral profile for each leader — what their patterns are, what activates them, what development would actually move them. A team map — how this management group functions collectively, and what structural conditions are contributing to what you're seeing. And specific structural recommendations — not general improvements, but changes connected to what the assessment actually found. Phase 1 gives you the picture. At the end of it, you decide whether you want to move to implementation. That's a deliberate structure — you're not committing to a full engagement on trust. You're committing to clarity first."</a:t>
             </a:r>
           </a:p>
           <a:p/>
@@ -781,7 +781,7 @@
           </a:p>
           <a:p>
             <a:r>
-              <a:t>Put away when: Owner has processed all three boxes</a:t>
+              <a:t>Put away when: Owner has processed all three boxes — "clarity first" signals the frame landed</a:t>
             </a:r>
           </a:p>
         </p:txBody>
@@ -851,7 +851,7 @@
           <a:lstStyle/>
           <a:p>
             <a:r>
-              <a:t>"Phase 1 is 13 weeks — assessment, interpretation, debrief. The first things you'll notice if we proceed to implementation are behavioral — your managers showing up differently in difficult situations. That typically happens within 60 to 90 days of well-implemented development work. The turnover shift follows, at 6 to 12 months. A culture that holds without you having to maintain it manually — that's 18 months or more. I'm not going to tell you this is fast. What I will tell you is that you've already seen what not doing it costs."</a:t>
+              <a:t>"Phase 1 is 13 weeks — assessment, interpretation, structural recommendations delivered. If you proceed to implementation, the first behavioral signals typically show up within 60 to 90 days — your managers functioning differently under pressure. Turnover shift follows at 6 to 12 months. A culture that sustains itself without you manually maintaining it — 18 months or more. I'm not going to tell you this is fast. What I will say is that you've already seen what fast gets you. Every training program that lasted 30 days was fast. This is different in kind, not just in content."</a:t>
             </a:r>
           </a:p>
           <a:p/>
@@ -867,7 +867,7 @@
           </a:p>
           <a:p>
             <a:r>
-              <a:t>Put away when: Owner acknowledges the timeline</a:t>
+              <a:t>Put away when: Owner acknowledges the timeline — "so Phase 1 is essentially this year..." signals it landed</a:t>
             </a:r>
           </a:p>
         </p:txBody>
@@ -937,7 +937,7 @@
           <a:lstStyle/>
           <a:p>
             <a:r>
-              <a:t>"Before you meet with your managers about this — here's the frame that will set things up well for you. The thing your OMs will want to know first is what this means for them — whether they're being evaluated, whether you'll have access to what they share, whether this is being done to them or with them. The confidentiality structure means their individual data stays with them — what you receive is the aggregate picture. That protection is what makes honest assessment possible. Your managers are not the problem here. They're the lever."</a:t>
+              <a:t>"When you bring this to your OMs, the first thing they'll want to know is what it means for them — whether they're being assessed, whether you'll have access to what they share. Here's the answer: their individual data stays with them. What you receive is the aggregate picture — how the team functions collectively and what the structure is contributing. That confidentiality isn't a courtesy — it's what makes honest assessment possible. An OM who's guarding what he says won't give you usable data. The protection is structural, not just a promise. Your managers are the lever here. They're not the problem — and how you introduce this will either confirm that or undo it."</a:t>
             </a:r>
           </a:p>
           <a:p/>
@@ -953,7 +953,7 @@
           </a:p>
           <a:p>
             <a:r>
-              <a:t>Put away when: Owner has language for how to introduce Andrew to OMs</a:t>
+              <a:t>Put away when: Owner has language for how to introduce Andrew to OMs — "so I'd say something like..." signals the frame landed</a:t>
             </a:r>
           </a:p>
         </p:txBody>

</xml_diff>